<commit_message>
Clarify slide 3 title and key takeaway
- Title: "방향이 어긋난 뒤에 알게 됩니다" -> "방향이 어긋날 위험이 있습니다"
- Takeaway: replace "모델의 지능보다 일하는 순서를 먼저 정합니다" with a plainer
  sentence naming what it compares and why it matters

Co-Authored-By: Claude Opus 5 <noreply@anthropic.com>
Claude-Session: https://claude.ai/code/session_015cu1phHjgbjCPUemRkBFgX
</commit_message>
<xml_diff>
--- a/presentation/Superpowers_Codex_10min.pptx
+++ b/presentation/Superpowers_Codex_10min.pptx
@@ -11682,7 +11682,7 @@
                 <a:ea typeface="Calibri" pitchFamily="34" charset="-122"/>
                 <a:cs typeface="Calibri" pitchFamily="34" charset="-120"/>
               </a:rPr>
-              <a:t>바로 코딩하면 빠르지만, 방향이 어긋난 뒤에 알게 됩니다</a:t>
+              <a:t>바로 코딩하면 빠르지만, 방향이 어긋날 위험이 있습니다</a:t>
             </a:r>
             <a:endParaRPr lang="en-US" sz="2400" dirty="0"/>
           </a:p>
@@ -12224,7 +12224,7 @@
                 <a:ea typeface="Calibri" pitchFamily="34" charset="-122"/>
                 <a:cs typeface="Calibri" pitchFamily="34" charset="-120"/>
               </a:rPr>
-              <a:t>핵심 — 모델의 지능보다 “일하는 순서”를 먼저 정합니다</a:t>
+              <a:t>핵심 — AI가 얼마나 똑똑한지보다, 어떤 순서로 일하게 하는지가 결과를 좌우합니다</a:t>
             </a:r>
             <a:endParaRPr lang="en-US" sz="1350" dirty="0"/>
           </a:p>

</xml_diff>

<commit_message>
Rebuild slide 7 around each stage's output
The old flow slide named the five stages but described them with noun
fragments ("질문 · 대안 · 설계"), so a beginner could not tell what any stage
actually produces or why the next one needs it.

- Split into two labelled bands: "무엇을 하는 단계인가" over "그래서 무엇이
  나오는가", linked by arrows, so the hand-off is the visible structure
- Name a concrete artifact per stage (구현 계획서, 테스트를 통과한 코드, …)
- Turn the debugging note into a labelled branch instead of a text bar
- Drop the summary bar the band labels now make redundant

Co-Authored-By: Claude Opus 5 <noreply@anthropic.com>
Claude-Session: https://claude.ai/code/session_015cu1phHjgbjCPUemRkBFgX
</commit_message>
<xml_diff>
--- a/presentation/Superpowers_Codex_10min.pptx
+++ b/presentation/Superpowers_Codex_10min.pptx
@@ -14454,7 +14454,7 @@
                 <a:ea typeface="Calibri" pitchFamily="34" charset="-122"/>
                 <a:cs typeface="Calibri" pitchFamily="34" charset="-120"/>
               </a:rPr>
-              <a:t>아이디어에서 완료까지, 한 줄로 이어집니다</a:t>
+              <a:t>앞 단계에서 나온 것이 다음 단계의 재료가 됩니다</a:t>
             </a:r>
             <a:endParaRPr lang="en-US" sz="2400" dirty="0"/>
           </a:p>
@@ -14501,18 +14501,57 @@
       </p:sp>
       <p:sp>
         <p:nvSpPr>
-          <p:cNvPr id="5" name="Shape 3"/>
+          <p:cNvPr id="5" name="Text 3"/>
+          <p:cNvSpPr txBox="1"/>
+          <p:nvPr/>
+        </p:nvSpPr>
+        <p:spPr>
+          <a:xfrm>
+            <a:off x="640080" y="1225296"/>
+            <a:ext cx="5486400" cy="237744"/>
+          </a:xfrm>
+          <a:prstGeom prst="rect">
+            <a:avLst/>
+          </a:prstGeom>
+          <a:noFill/>
+          <a:ln/>
+        </p:spPr>
+        <p:txBody>
+          <a:bodyPr wrap="square" lIns="0" tIns="0" rIns="0" bIns="0" rtlCol="0" anchor="ctr"/>
+          <a:lstStyle/>
+          <a:p>
+            <a:pPr indent="0" marL="0">
+              <a:buNone/>
+            </a:pPr>
+            <a:r>
+              <a:rPr lang="en-US" sz="1050" b="1" spc="60" kern="0" dirty="0">
+                <a:solidFill>
+                  <a:srgbClr val="8A94A6"/>
+                </a:solidFill>
+                <a:latin typeface="Calibri" pitchFamily="34" charset="0"/>
+                <a:ea typeface="Calibri" pitchFamily="34" charset="-122"/>
+                <a:cs typeface="Calibri" pitchFamily="34" charset="-120"/>
+              </a:rPr>
+              <a:t>무엇을 하는 단계인가</a:t>
+            </a:r>
+            <a:endParaRPr lang="en-US" sz="1050" dirty="0"/>
+          </a:p>
+        </p:txBody>
+      </p:sp>
+      <p:sp>
+        <p:nvSpPr>
+          <p:cNvPr id="6" name="Shape 4"/>
           <p:cNvSpPr/>
           <p:nvPr/>
         </p:nvSpPr>
         <p:spPr>
           <a:xfrm>
-            <a:off x="640080" y="1664208"/>
-            <a:ext cx="2006742" cy="2103120"/>
+            <a:off x="640080" y="1517904"/>
+            <a:ext cx="2006742" cy="950976"/>
           </a:xfrm>
           <a:prstGeom prst="roundRect">
             <a:avLst>
-              <a:gd name="adj" fmla="val 3190"/>
+              <a:gd name="adj" fmla="val 6731"/>
             </a:avLst>
           </a:prstGeom>
           <a:solidFill>
@@ -14523,30 +14562,30 @@
       </p:sp>
       <p:sp>
         <p:nvSpPr>
-          <p:cNvPr id="6" name="Text 4"/>
-          <p:cNvSpPr txBox="1"/>
-          <p:nvPr/>
-        </p:nvSpPr>
-        <p:spPr>
-          <a:xfrm>
-            <a:off x="877824" y="1920240"/>
-            <a:ext cx="1531254" cy="256032"/>
-          </a:xfrm>
-          <a:prstGeom prst="rect">
-            <a:avLst/>
-          </a:prstGeom>
-          <a:noFill/>
-          <a:ln/>
-        </p:spPr>
-        <p:txBody>
-          <a:bodyPr wrap="square" lIns="0" tIns="0" rIns="0" bIns="0" rtlCol="0" anchor="ctr"/>
-          <a:lstStyle/>
-          <a:p>
-            <a:pPr indent="0" marL="0">
-              <a:buNone/>
-            </a:pPr>
-            <a:r>
-              <a:rPr lang="en-US" sz="1100" b="1" dirty="0">
+          <p:cNvPr id="7" name="Text 5"/>
+          <p:cNvSpPr txBox="1"/>
+          <p:nvPr/>
+        </p:nvSpPr>
+        <p:spPr>
+          <a:xfrm>
+            <a:off x="877824" y="1664208"/>
+            <a:ext cx="1531254" cy="219456"/>
+          </a:xfrm>
+          <a:prstGeom prst="rect">
+            <a:avLst/>
+          </a:prstGeom>
+          <a:noFill/>
+          <a:ln/>
+        </p:spPr>
+        <p:txBody>
+          <a:bodyPr wrap="square" lIns="0" tIns="0" rIns="0" bIns="0" rtlCol="0" anchor="ctr"/>
+          <a:lstStyle/>
+          <a:p>
+            <a:pPr indent="0" marL="0">
+              <a:buNone/>
+            </a:pPr>
+            <a:r>
+              <a:rPr lang="en-US" sz="1050" b="1" dirty="0">
                 <a:solidFill>
                   <a:srgbClr val="8A94A6"/>
                 </a:solidFill>
@@ -14556,20 +14595,20 @@
               </a:rPr>
               <a:t>01</a:t>
             </a:r>
-            <a:endParaRPr lang="en-US" sz="1100" dirty="0"/>
-          </a:p>
-        </p:txBody>
-      </p:sp>
-      <p:sp>
-        <p:nvSpPr>
-          <p:cNvPr id="7" name="Text 5"/>
-          <p:cNvSpPr txBox="1"/>
-          <p:nvPr/>
-        </p:nvSpPr>
-        <p:spPr>
-          <a:xfrm>
-            <a:off x="877824" y="2322576"/>
-            <a:ext cx="1531254" cy="603504"/>
+            <a:endParaRPr lang="en-US" sz="1050" dirty="0"/>
+          </a:p>
+        </p:txBody>
+      </p:sp>
+      <p:sp>
+        <p:nvSpPr>
+          <p:cNvPr id="8" name="Text 6"/>
+          <p:cNvSpPr txBox="1"/>
+          <p:nvPr/>
+        </p:nvSpPr>
+        <p:spPr>
+          <a:xfrm>
+            <a:off x="877824" y="1938528"/>
+            <a:ext cx="1531254" cy="420624"/>
           </a:xfrm>
           <a:prstGeom prst="rect">
             <a:avLst/>
@@ -14583,12 +14622,12 @@
           <a:p>
             <a:pPr indent="0" marL="0">
               <a:lnSpc>
-                <a:spcPct val="110000"/>
+                <a:spcPct val="105000"/>
               </a:lnSpc>
               <a:buNone/>
             </a:pPr>
             <a:r>
-              <a:rPr lang="en-US" sz="1450" b="1" dirty="0">
+              <a:rPr lang="en-US" sz="1400" b="1" dirty="0">
                 <a:solidFill>
                   <a:srgbClr val="0F1B33"/>
                 </a:solidFill>
@@ -14598,49 +14637,7 @@
               </a:rPr>
               <a:t>아이디어</a:t>
             </a:r>
-            <a:endParaRPr lang="en-US" sz="1450" dirty="0"/>
-          </a:p>
-        </p:txBody>
-      </p:sp>
-      <p:sp>
-        <p:nvSpPr>
-          <p:cNvPr id="8" name="Text 6"/>
-          <p:cNvSpPr txBox="1"/>
-          <p:nvPr/>
-        </p:nvSpPr>
-        <p:spPr>
-          <a:xfrm>
-            <a:off x="877824" y="2999232"/>
-            <a:ext cx="1531254" cy="457200"/>
-          </a:xfrm>
-          <a:prstGeom prst="rect">
-            <a:avLst/>
-          </a:prstGeom>
-          <a:noFill/>
-          <a:ln/>
-        </p:spPr>
-        <p:txBody>
-          <a:bodyPr wrap="square" lIns="0" tIns="0" rIns="0" bIns="0" rtlCol="0" anchor="ctr"/>
-          <a:lstStyle/>
-          <a:p>
-            <a:pPr indent="0" marL="0">
-              <a:lnSpc>
-                <a:spcPct val="120000"/>
-              </a:lnSpc>
-              <a:buNone/>
-            </a:pPr>
-            <a:r>
-              <a:rPr lang="en-US" sz="1100" dirty="0">
-                <a:solidFill>
-                  <a:srgbClr val="5B6577"/>
-                </a:solidFill>
-                <a:latin typeface="Calibri" pitchFamily="34" charset="0"/>
-                <a:ea typeface="Calibri" pitchFamily="34" charset="-122"/>
-                <a:cs typeface="Calibri" pitchFamily="34" charset="-120"/>
-              </a:rPr>
-              <a:t>만들고 싶은 것</a:t>
-            </a:r>
-            <a:endParaRPr lang="en-US" sz="1100" dirty="0"/>
+            <a:endParaRPr lang="en-US" sz="1400" dirty="0"/>
           </a:p>
         </p:txBody>
       </p:sp>
@@ -14652,8 +14649,8 @@
         </p:nvSpPr>
         <p:spPr>
           <a:xfrm>
-            <a:off x="2646822" y="2532888"/>
-            <a:ext cx="219456" cy="365760"/>
+            <a:off x="2646822" y="1828800"/>
+            <a:ext cx="219456" cy="329184"/>
           </a:xfrm>
           <a:prstGeom prst="rect">
             <a:avLst/>
@@ -14691,12 +14688,12 @@
         </p:nvSpPr>
         <p:spPr>
           <a:xfrm>
-            <a:off x="2866278" y="1664208"/>
-            <a:ext cx="2006742" cy="2103120"/>
+            <a:off x="2866278" y="1517904"/>
+            <a:ext cx="2006742" cy="950976"/>
           </a:xfrm>
           <a:prstGeom prst="roundRect">
             <a:avLst>
-              <a:gd name="adj" fmla="val 3190"/>
+              <a:gd name="adj" fmla="val 6731"/>
             </a:avLst>
           </a:prstGeom>
           <a:solidFill>
@@ -14713,24 +14710,24 @@
         </p:nvSpPr>
         <p:spPr>
           <a:xfrm>
-            <a:off x="3104022" y="1920240"/>
-            <a:ext cx="1531254" cy="256032"/>
-          </a:xfrm>
-          <a:prstGeom prst="rect">
-            <a:avLst/>
-          </a:prstGeom>
-          <a:noFill/>
-          <a:ln/>
-        </p:spPr>
-        <p:txBody>
-          <a:bodyPr wrap="square" lIns="0" tIns="0" rIns="0" bIns="0" rtlCol="0" anchor="ctr"/>
-          <a:lstStyle/>
-          <a:p>
-            <a:pPr indent="0" marL="0">
-              <a:buNone/>
-            </a:pPr>
-            <a:r>
-              <a:rPr lang="en-US" sz="1100" b="1" dirty="0">
+            <a:off x="3104022" y="1664208"/>
+            <a:ext cx="1531254" cy="219456"/>
+          </a:xfrm>
+          <a:prstGeom prst="rect">
+            <a:avLst/>
+          </a:prstGeom>
+          <a:noFill/>
+          <a:ln/>
+        </p:spPr>
+        <p:txBody>
+          <a:bodyPr wrap="square" lIns="0" tIns="0" rIns="0" bIns="0" rtlCol="0" anchor="ctr"/>
+          <a:lstStyle/>
+          <a:p>
+            <a:pPr indent="0" marL="0">
+              <a:buNone/>
+            </a:pPr>
+            <a:r>
+              <a:rPr lang="en-US" sz="1050" b="1" dirty="0">
                 <a:solidFill>
                   <a:srgbClr val="8A94A6"/>
                 </a:solidFill>
@@ -14740,7 +14737,7 @@
               </a:rPr>
               <a:t>02</a:t>
             </a:r>
-            <a:endParaRPr lang="en-US" sz="1100" dirty="0"/>
+            <a:endParaRPr lang="en-US" sz="1050" dirty="0"/>
           </a:p>
         </p:txBody>
       </p:sp>
@@ -14752,8 +14749,8 @@
         </p:nvSpPr>
         <p:spPr>
           <a:xfrm>
-            <a:off x="3104022" y="2322576"/>
-            <a:ext cx="1531254" cy="603504"/>
+            <a:off x="3104022" y="1938528"/>
+            <a:ext cx="1531254" cy="420624"/>
           </a:xfrm>
           <a:prstGeom prst="rect">
             <a:avLst/>
@@ -14767,12 +14764,12 @@
           <a:p>
             <a:pPr indent="0" marL="0">
               <a:lnSpc>
-                <a:spcPct val="110000"/>
+                <a:spcPct val="105000"/>
               </a:lnSpc>
               <a:buNone/>
             </a:pPr>
             <a:r>
-              <a:rPr lang="en-US" sz="1450" b="1" dirty="0">
+              <a:rPr lang="en-US" sz="1400" b="1" dirty="0">
                 <a:solidFill>
                   <a:srgbClr val="0F1B33"/>
                 </a:solidFill>
@@ -14782,7 +14779,7 @@
               </a:rPr>
               <a:t>Brainstorming</a:t>
             </a:r>
-            <a:endParaRPr lang="en-US" sz="1450" dirty="0"/>
+            <a:endParaRPr lang="en-US" sz="1400" dirty="0"/>
           </a:p>
         </p:txBody>
       </p:sp>
@@ -14794,50 +14791,8 @@
         </p:nvSpPr>
         <p:spPr>
           <a:xfrm>
-            <a:off x="3104022" y="2999232"/>
-            <a:ext cx="1531254" cy="457200"/>
-          </a:xfrm>
-          <a:prstGeom prst="rect">
-            <a:avLst/>
-          </a:prstGeom>
-          <a:noFill/>
-          <a:ln/>
-        </p:spPr>
-        <p:txBody>
-          <a:bodyPr wrap="square" lIns="0" tIns="0" rIns="0" bIns="0" rtlCol="0" anchor="ctr"/>
-          <a:lstStyle/>
-          <a:p>
-            <a:pPr indent="0" marL="0">
-              <a:lnSpc>
-                <a:spcPct val="120000"/>
-              </a:lnSpc>
-              <a:buNone/>
-            </a:pPr>
-            <a:r>
-              <a:rPr lang="en-US" sz="1100" dirty="0">
-                <a:solidFill>
-                  <a:srgbClr val="5B6577"/>
-                </a:solidFill>
-                <a:latin typeface="Calibri" pitchFamily="34" charset="0"/>
-                <a:ea typeface="Calibri" pitchFamily="34" charset="-122"/>
-                <a:cs typeface="Calibri" pitchFamily="34" charset="-120"/>
-              </a:rPr>
-              <a:t>질문 · 대안 · 설계</a:t>
-            </a:r>
-            <a:endParaRPr lang="en-US" sz="1100" dirty="0"/>
-          </a:p>
-        </p:txBody>
-      </p:sp>
-      <p:sp>
-        <p:nvSpPr>
-          <p:cNvPr id="14" name="Text 12"/>
-          <p:cNvSpPr txBox="1"/>
-          <p:nvPr/>
-        </p:nvSpPr>
-        <p:spPr>
-          <a:xfrm>
-            <a:off x="4873020" y="2532888"/>
-            <a:ext cx="219456" cy="365760"/>
+            <a:off x="4873020" y="1828800"/>
+            <a:ext cx="219456" cy="329184"/>
           </a:xfrm>
           <a:prstGeom prst="rect">
             <a:avLst/>
@@ -14869,18 +14824,18 @@
       </p:sp>
       <p:sp>
         <p:nvSpPr>
-          <p:cNvPr id="15" name="Shape 13"/>
+          <p:cNvPr id="14" name="Shape 12"/>
           <p:cNvSpPr/>
           <p:nvPr/>
         </p:nvSpPr>
         <p:spPr>
           <a:xfrm>
-            <a:off x="5092476" y="1664208"/>
-            <a:ext cx="2006742" cy="2103120"/>
+            <a:off x="5092476" y="1517904"/>
+            <a:ext cx="2006742" cy="950976"/>
           </a:xfrm>
           <a:prstGeom prst="roundRect">
             <a:avLst>
-              <a:gd name="adj" fmla="val 3190"/>
+              <a:gd name="adj" fmla="val 6731"/>
             </a:avLst>
           </a:prstGeom>
           <a:solidFill>
@@ -14891,30 +14846,111 @@
       </p:sp>
       <p:sp>
         <p:nvSpPr>
+          <p:cNvPr id="15" name="Text 13"/>
+          <p:cNvSpPr txBox="1"/>
+          <p:nvPr/>
+        </p:nvSpPr>
+        <p:spPr>
+          <a:xfrm>
+            <a:off x="5330220" y="1664208"/>
+            <a:ext cx="1531254" cy="219456"/>
+          </a:xfrm>
+          <a:prstGeom prst="rect">
+            <a:avLst/>
+          </a:prstGeom>
+          <a:noFill/>
+          <a:ln/>
+        </p:spPr>
+        <p:txBody>
+          <a:bodyPr wrap="square" lIns="0" tIns="0" rIns="0" bIns="0" rtlCol="0" anchor="ctr"/>
+          <a:lstStyle/>
+          <a:p>
+            <a:pPr indent="0" marL="0">
+              <a:buNone/>
+            </a:pPr>
+            <a:r>
+              <a:rPr lang="en-US" sz="1050" b="1" dirty="0">
+                <a:solidFill>
+                  <a:srgbClr val="8A94A6"/>
+                </a:solidFill>
+                <a:latin typeface="Calibri" pitchFamily="34" charset="0"/>
+                <a:ea typeface="Calibri" pitchFamily="34" charset="-122"/>
+                <a:cs typeface="Calibri" pitchFamily="34" charset="-120"/>
+              </a:rPr>
+              <a:t>03</a:t>
+            </a:r>
+            <a:endParaRPr lang="en-US" sz="1050" dirty="0"/>
+          </a:p>
+        </p:txBody>
+      </p:sp>
+      <p:sp>
+        <p:nvSpPr>
           <p:cNvPr id="16" name="Text 14"/>
           <p:cNvSpPr txBox="1"/>
           <p:nvPr/>
         </p:nvSpPr>
         <p:spPr>
           <a:xfrm>
-            <a:off x="5330220" y="1920240"/>
-            <a:ext cx="1531254" cy="256032"/>
-          </a:xfrm>
-          <a:prstGeom prst="rect">
-            <a:avLst/>
-          </a:prstGeom>
-          <a:noFill/>
-          <a:ln/>
-        </p:spPr>
-        <p:txBody>
-          <a:bodyPr wrap="square" lIns="0" tIns="0" rIns="0" bIns="0" rtlCol="0" anchor="ctr"/>
-          <a:lstStyle/>
-          <a:p>
-            <a:pPr indent="0" marL="0">
-              <a:buNone/>
-            </a:pPr>
-            <a:r>
-              <a:rPr lang="en-US" sz="1100" b="1" dirty="0">
+            <a:off x="5330220" y="1938528"/>
+            <a:ext cx="1531254" cy="420624"/>
+          </a:xfrm>
+          <a:prstGeom prst="rect">
+            <a:avLst/>
+          </a:prstGeom>
+          <a:noFill/>
+          <a:ln/>
+        </p:spPr>
+        <p:txBody>
+          <a:bodyPr wrap="square" lIns="0" tIns="0" rIns="0" bIns="0" rtlCol="0" anchor="ctr"/>
+          <a:lstStyle/>
+          <a:p>
+            <a:pPr indent="0" marL="0">
+              <a:lnSpc>
+                <a:spcPct val="105000"/>
+              </a:lnSpc>
+              <a:buNone/>
+            </a:pPr>
+            <a:r>
+              <a:rPr lang="en-US" sz="1400" b="1" dirty="0">
+                <a:solidFill>
+                  <a:srgbClr val="0F1B33"/>
+                </a:solidFill>
+                <a:latin typeface="Calibri" pitchFamily="34" charset="0"/>
+                <a:ea typeface="Calibri" pitchFamily="34" charset="-122"/>
+                <a:cs typeface="Calibri" pitchFamily="34" charset="-120"/>
+              </a:rPr>
+              <a:t>Writing Plans</a:t>
+            </a:r>
+            <a:endParaRPr lang="en-US" sz="1400" dirty="0"/>
+          </a:p>
+        </p:txBody>
+      </p:sp>
+      <p:sp>
+        <p:nvSpPr>
+          <p:cNvPr id="17" name="Text 15"/>
+          <p:cNvSpPr txBox="1"/>
+          <p:nvPr/>
+        </p:nvSpPr>
+        <p:spPr>
+          <a:xfrm>
+            <a:off x="7099219" y="1828800"/>
+            <a:ext cx="219456" cy="329184"/>
+          </a:xfrm>
+          <a:prstGeom prst="rect">
+            <a:avLst/>
+          </a:prstGeom>
+          <a:noFill/>
+          <a:ln/>
+        </p:spPr>
+        <p:txBody>
+          <a:bodyPr wrap="square" lIns="0" tIns="0" rIns="0" bIns="0" rtlCol="0" anchor="ctr"/>
+          <a:lstStyle/>
+          <a:p>
+            <a:pPr algn="ctr" indent="0" marL="0">
+              <a:buNone/>
+            </a:pPr>
+            <a:r>
+              <a:rPr lang="en-US" sz="1300" b="1" dirty="0">
                 <a:solidFill>
                   <a:srgbClr val="8A94A6"/>
                 </a:solidFill>
@@ -14922,129 +14958,6 @@
                 <a:ea typeface="Calibri" pitchFamily="34" charset="-122"/>
                 <a:cs typeface="Calibri" pitchFamily="34" charset="-120"/>
               </a:rPr>
-              <a:t>03</a:t>
-            </a:r>
-            <a:endParaRPr lang="en-US" sz="1100" dirty="0"/>
-          </a:p>
-        </p:txBody>
-      </p:sp>
-      <p:sp>
-        <p:nvSpPr>
-          <p:cNvPr id="17" name="Text 15"/>
-          <p:cNvSpPr txBox="1"/>
-          <p:nvPr/>
-        </p:nvSpPr>
-        <p:spPr>
-          <a:xfrm>
-            <a:off x="5330220" y="2322576"/>
-            <a:ext cx="1531254" cy="603504"/>
-          </a:xfrm>
-          <a:prstGeom prst="rect">
-            <a:avLst/>
-          </a:prstGeom>
-          <a:noFill/>
-          <a:ln/>
-        </p:spPr>
-        <p:txBody>
-          <a:bodyPr wrap="square" lIns="0" tIns="0" rIns="0" bIns="0" rtlCol="0" anchor="ctr"/>
-          <a:lstStyle/>
-          <a:p>
-            <a:pPr indent="0" marL="0">
-              <a:lnSpc>
-                <a:spcPct val="110000"/>
-              </a:lnSpc>
-              <a:buNone/>
-            </a:pPr>
-            <a:r>
-              <a:rPr lang="en-US" sz="1450" b="1" dirty="0">
-                <a:solidFill>
-                  <a:srgbClr val="0F1B33"/>
-                </a:solidFill>
-                <a:latin typeface="Calibri" pitchFamily="34" charset="0"/>
-                <a:ea typeface="Calibri" pitchFamily="34" charset="-122"/>
-                <a:cs typeface="Calibri" pitchFamily="34" charset="-120"/>
-              </a:rPr>
-              <a:t>Writing Plans</a:t>
-            </a:r>
-            <a:endParaRPr lang="en-US" sz="1450" dirty="0"/>
-          </a:p>
-        </p:txBody>
-      </p:sp>
-      <p:sp>
-        <p:nvSpPr>
-          <p:cNvPr id="18" name="Text 16"/>
-          <p:cNvSpPr txBox="1"/>
-          <p:nvPr/>
-        </p:nvSpPr>
-        <p:spPr>
-          <a:xfrm>
-            <a:off x="5330220" y="2999232"/>
-            <a:ext cx="1531254" cy="457200"/>
-          </a:xfrm>
-          <a:prstGeom prst="rect">
-            <a:avLst/>
-          </a:prstGeom>
-          <a:noFill/>
-          <a:ln/>
-        </p:spPr>
-        <p:txBody>
-          <a:bodyPr wrap="square" lIns="0" tIns="0" rIns="0" bIns="0" rtlCol="0" anchor="ctr"/>
-          <a:lstStyle/>
-          <a:p>
-            <a:pPr indent="0" marL="0">
-              <a:lnSpc>
-                <a:spcPct val="120000"/>
-              </a:lnSpc>
-              <a:buNone/>
-            </a:pPr>
-            <a:r>
-              <a:rPr lang="en-US" sz="1100" dirty="0">
-                <a:solidFill>
-                  <a:srgbClr val="5B6577"/>
-                </a:solidFill>
-                <a:latin typeface="Calibri" pitchFamily="34" charset="0"/>
-                <a:ea typeface="Calibri" pitchFamily="34" charset="-122"/>
-                <a:cs typeface="Calibri" pitchFamily="34" charset="-120"/>
-              </a:rPr>
-              <a:t>파일 · 테스트 · 순서</a:t>
-            </a:r>
-            <a:endParaRPr lang="en-US" sz="1100" dirty="0"/>
-          </a:p>
-        </p:txBody>
-      </p:sp>
-      <p:sp>
-        <p:nvSpPr>
-          <p:cNvPr id="19" name="Text 17"/>
-          <p:cNvSpPr txBox="1"/>
-          <p:nvPr/>
-        </p:nvSpPr>
-        <p:spPr>
-          <a:xfrm>
-            <a:off x="7099219" y="2532888"/>
-            <a:ext cx="219456" cy="365760"/>
-          </a:xfrm>
-          <a:prstGeom prst="rect">
-            <a:avLst/>
-          </a:prstGeom>
-          <a:noFill/>
-          <a:ln/>
-        </p:spPr>
-        <p:txBody>
-          <a:bodyPr wrap="square" lIns="0" tIns="0" rIns="0" bIns="0" rtlCol="0" anchor="ctr"/>
-          <a:lstStyle/>
-          <a:p>
-            <a:pPr algn="ctr" indent="0" marL="0">
-              <a:buNone/>
-            </a:pPr>
-            <a:r>
-              <a:rPr lang="en-US" sz="1300" b="1" dirty="0">
-                <a:solidFill>
-                  <a:srgbClr val="8A94A6"/>
-                </a:solidFill>
-                <a:latin typeface="Calibri" pitchFamily="34" charset="0"/>
-                <a:ea typeface="Calibri" pitchFamily="34" charset="-122"/>
-                <a:cs typeface="Calibri" pitchFamily="34" charset="-120"/>
-              </a:rPr>
               <a:t>→</a:t>
             </a:r>
             <a:endParaRPr lang="en-US" sz="1300" dirty="0"/>
@@ -15053,18 +14966,18 @@
       </p:sp>
       <p:sp>
         <p:nvSpPr>
-          <p:cNvPr id="20" name="Shape 18"/>
+          <p:cNvPr id="18" name="Shape 16"/>
           <p:cNvSpPr/>
           <p:nvPr/>
         </p:nvSpPr>
         <p:spPr>
           <a:xfrm>
-            <a:off x="7318675" y="1664208"/>
-            <a:ext cx="2006742" cy="2103120"/>
+            <a:off x="7318675" y="1517904"/>
+            <a:ext cx="2006742" cy="950976"/>
           </a:xfrm>
           <a:prstGeom prst="roundRect">
             <a:avLst>
-              <a:gd name="adj" fmla="val 3190"/>
+              <a:gd name="adj" fmla="val 6731"/>
             </a:avLst>
           </a:prstGeom>
           <a:solidFill>
@@ -15075,137 +14988,95 @@
       </p:sp>
       <p:sp>
         <p:nvSpPr>
+          <p:cNvPr id="19" name="Text 17"/>
+          <p:cNvSpPr txBox="1"/>
+          <p:nvPr/>
+        </p:nvSpPr>
+        <p:spPr>
+          <a:xfrm>
+            <a:off x="7556419" y="1664208"/>
+            <a:ext cx="1531254" cy="219456"/>
+          </a:xfrm>
+          <a:prstGeom prst="rect">
+            <a:avLst/>
+          </a:prstGeom>
+          <a:noFill/>
+          <a:ln/>
+        </p:spPr>
+        <p:txBody>
+          <a:bodyPr wrap="square" lIns="0" tIns="0" rIns="0" bIns="0" rtlCol="0" anchor="ctr"/>
+          <a:lstStyle/>
+          <a:p>
+            <a:pPr indent="0" marL="0">
+              <a:buNone/>
+            </a:pPr>
+            <a:r>
+              <a:rPr lang="en-US" sz="1050" b="1" dirty="0">
+                <a:solidFill>
+                  <a:srgbClr val="9FB8FF"/>
+                </a:solidFill>
+                <a:latin typeface="Calibri" pitchFamily="34" charset="0"/>
+                <a:ea typeface="Calibri" pitchFamily="34" charset="-122"/>
+                <a:cs typeface="Calibri" pitchFamily="34" charset="-120"/>
+              </a:rPr>
+              <a:t>04</a:t>
+            </a:r>
+            <a:endParaRPr lang="en-US" sz="1050" dirty="0"/>
+          </a:p>
+        </p:txBody>
+      </p:sp>
+      <p:sp>
+        <p:nvSpPr>
+          <p:cNvPr id="20" name="Text 18"/>
+          <p:cNvSpPr txBox="1"/>
+          <p:nvPr/>
+        </p:nvSpPr>
+        <p:spPr>
+          <a:xfrm>
+            <a:off x="7556419" y="1938528"/>
+            <a:ext cx="1531254" cy="420624"/>
+          </a:xfrm>
+          <a:prstGeom prst="rect">
+            <a:avLst/>
+          </a:prstGeom>
+          <a:noFill/>
+          <a:ln/>
+        </p:spPr>
+        <p:txBody>
+          <a:bodyPr wrap="square" lIns="0" tIns="0" rIns="0" bIns="0" rtlCol="0" anchor="ctr"/>
+          <a:lstStyle/>
+          <a:p>
+            <a:pPr indent="0" marL="0">
+              <a:lnSpc>
+                <a:spcPct val="105000"/>
+              </a:lnSpc>
+              <a:buNone/>
+            </a:pPr>
+            <a:r>
+              <a:rPr lang="en-US" sz="1400" b="1" dirty="0">
+                <a:solidFill>
+                  <a:srgbClr val="FFFFFF"/>
+                </a:solidFill>
+                <a:latin typeface="Calibri" pitchFamily="34" charset="0"/>
+                <a:ea typeface="Calibri" pitchFamily="34" charset="-122"/>
+                <a:cs typeface="Calibri" pitchFamily="34" charset="-120"/>
+              </a:rPr>
+              <a:t>TDD 구현</a:t>
+            </a:r>
+            <a:endParaRPr lang="en-US" sz="1400" dirty="0"/>
+          </a:p>
+        </p:txBody>
+      </p:sp>
+      <p:sp>
+        <p:nvSpPr>
           <p:cNvPr id="21" name="Text 19"/>
           <p:cNvSpPr txBox="1"/>
           <p:nvPr/>
         </p:nvSpPr>
         <p:spPr>
           <a:xfrm>
-            <a:off x="7556419" y="1920240"/>
-            <a:ext cx="1531254" cy="256032"/>
-          </a:xfrm>
-          <a:prstGeom prst="rect">
-            <a:avLst/>
-          </a:prstGeom>
-          <a:noFill/>
-          <a:ln/>
-        </p:spPr>
-        <p:txBody>
-          <a:bodyPr wrap="square" lIns="0" tIns="0" rIns="0" bIns="0" rtlCol="0" anchor="ctr"/>
-          <a:lstStyle/>
-          <a:p>
-            <a:pPr indent="0" marL="0">
-              <a:buNone/>
-            </a:pPr>
-            <a:r>
-              <a:rPr lang="en-US" sz="1100" b="1" dirty="0">
-                <a:solidFill>
-                  <a:srgbClr val="9FB8FF"/>
-                </a:solidFill>
-                <a:latin typeface="Calibri" pitchFamily="34" charset="0"/>
-                <a:ea typeface="Calibri" pitchFamily="34" charset="-122"/>
-                <a:cs typeface="Calibri" pitchFamily="34" charset="-120"/>
-              </a:rPr>
-              <a:t>04</a:t>
-            </a:r>
-            <a:endParaRPr lang="en-US" sz="1100" dirty="0"/>
-          </a:p>
-        </p:txBody>
-      </p:sp>
-      <p:sp>
-        <p:nvSpPr>
-          <p:cNvPr id="22" name="Text 20"/>
-          <p:cNvSpPr txBox="1"/>
-          <p:nvPr/>
-        </p:nvSpPr>
-        <p:spPr>
-          <a:xfrm>
-            <a:off x="7556419" y="2322576"/>
-            <a:ext cx="1531254" cy="603504"/>
-          </a:xfrm>
-          <a:prstGeom prst="rect">
-            <a:avLst/>
-          </a:prstGeom>
-          <a:noFill/>
-          <a:ln/>
-        </p:spPr>
-        <p:txBody>
-          <a:bodyPr wrap="square" lIns="0" tIns="0" rIns="0" bIns="0" rtlCol="0" anchor="ctr"/>
-          <a:lstStyle/>
-          <a:p>
-            <a:pPr indent="0" marL="0">
-              <a:lnSpc>
-                <a:spcPct val="110000"/>
-              </a:lnSpc>
-              <a:buNone/>
-            </a:pPr>
-            <a:r>
-              <a:rPr lang="en-US" sz="1450" b="1" dirty="0">
-                <a:solidFill>
-                  <a:srgbClr val="FFFFFF"/>
-                </a:solidFill>
-                <a:latin typeface="Calibri" pitchFamily="34" charset="0"/>
-                <a:ea typeface="Calibri" pitchFamily="34" charset="-122"/>
-                <a:cs typeface="Calibri" pitchFamily="34" charset="-120"/>
-              </a:rPr>
-              <a:t>TDD 구현</a:t>
-            </a:r>
-            <a:endParaRPr lang="en-US" sz="1450" dirty="0"/>
-          </a:p>
-        </p:txBody>
-      </p:sp>
-      <p:sp>
-        <p:nvSpPr>
-          <p:cNvPr id="23" name="Text 21"/>
-          <p:cNvSpPr txBox="1"/>
-          <p:nvPr/>
-        </p:nvSpPr>
-        <p:spPr>
-          <a:xfrm>
-            <a:off x="7556419" y="2999232"/>
-            <a:ext cx="1531254" cy="457200"/>
-          </a:xfrm>
-          <a:prstGeom prst="rect">
-            <a:avLst/>
-          </a:prstGeom>
-          <a:noFill/>
-          <a:ln/>
-        </p:spPr>
-        <p:txBody>
-          <a:bodyPr wrap="square" lIns="0" tIns="0" rIns="0" bIns="0" rtlCol="0" anchor="ctr"/>
-          <a:lstStyle/>
-          <a:p>
-            <a:pPr indent="0" marL="0">
-              <a:lnSpc>
-                <a:spcPct val="120000"/>
-              </a:lnSpc>
-              <a:buNone/>
-            </a:pPr>
-            <a:r>
-              <a:rPr lang="en-US" sz="1100" dirty="0">
-                <a:solidFill>
-                  <a:srgbClr val="E4EBFB"/>
-                </a:solidFill>
-                <a:latin typeface="Calibri" pitchFamily="34" charset="0"/>
-                <a:ea typeface="Calibri" pitchFamily="34" charset="-122"/>
-                <a:cs typeface="Calibri" pitchFamily="34" charset="-120"/>
-              </a:rPr>
-              <a:t>RED → GREEN</a:t>
-            </a:r>
-            <a:endParaRPr lang="en-US" sz="1100" dirty="0"/>
-          </a:p>
-        </p:txBody>
-      </p:sp>
-      <p:sp>
-        <p:nvSpPr>
-          <p:cNvPr id="24" name="Text 22"/>
-          <p:cNvSpPr txBox="1"/>
-          <p:nvPr/>
-        </p:nvSpPr>
-        <p:spPr>
-          <a:xfrm>
-            <a:off x="9325417" y="2532888"/>
-            <a:ext cx="219456" cy="365760"/>
+            <a:off x="9325417" y="1828800"/>
+            <a:ext cx="219456" cy="329184"/>
           </a:xfrm>
           <a:prstGeom prst="rect">
             <a:avLst/>
@@ -15237,18 +15108,18 @@
       </p:sp>
       <p:sp>
         <p:nvSpPr>
-          <p:cNvPr id="25" name="Shape 23"/>
+          <p:cNvPr id="22" name="Shape 20"/>
           <p:cNvSpPr/>
           <p:nvPr/>
         </p:nvSpPr>
         <p:spPr>
           <a:xfrm>
-            <a:off x="9544873" y="1664208"/>
-            <a:ext cx="2006742" cy="2103120"/>
+            <a:off x="9544873" y="1517904"/>
+            <a:ext cx="2006742" cy="950976"/>
           </a:xfrm>
           <a:prstGeom prst="roundRect">
             <a:avLst>
-              <a:gd name="adj" fmla="val 3190"/>
+              <a:gd name="adj" fmla="val 6731"/>
             </a:avLst>
           </a:prstGeom>
           <a:solidFill>
@@ -15259,141 +15130,718 @@
       </p:sp>
       <p:sp>
         <p:nvSpPr>
+          <p:cNvPr id="23" name="Text 21"/>
+          <p:cNvSpPr txBox="1"/>
+          <p:nvPr/>
+        </p:nvSpPr>
+        <p:spPr>
+          <a:xfrm>
+            <a:off x="9782617" y="1664208"/>
+            <a:ext cx="1531254" cy="219456"/>
+          </a:xfrm>
+          <a:prstGeom prst="rect">
+            <a:avLst/>
+          </a:prstGeom>
+          <a:noFill/>
+          <a:ln/>
+        </p:spPr>
+        <p:txBody>
+          <a:bodyPr wrap="square" lIns="0" tIns="0" rIns="0" bIns="0" rtlCol="0" anchor="ctr"/>
+          <a:lstStyle/>
+          <a:p>
+            <a:pPr indent="0" marL="0">
+              <a:buNone/>
+            </a:pPr>
+            <a:r>
+              <a:rPr lang="en-US" sz="1050" b="1" dirty="0">
+                <a:solidFill>
+                  <a:srgbClr val="9FB8FF"/>
+                </a:solidFill>
+                <a:latin typeface="Calibri" pitchFamily="34" charset="0"/>
+                <a:ea typeface="Calibri" pitchFamily="34" charset="-122"/>
+                <a:cs typeface="Calibri" pitchFamily="34" charset="-120"/>
+              </a:rPr>
+              <a:t>05</a:t>
+            </a:r>
+            <a:endParaRPr lang="en-US" sz="1050" dirty="0"/>
+          </a:p>
+        </p:txBody>
+      </p:sp>
+      <p:sp>
+        <p:nvSpPr>
+          <p:cNvPr id="24" name="Text 22"/>
+          <p:cNvSpPr txBox="1"/>
+          <p:nvPr/>
+        </p:nvSpPr>
+        <p:spPr>
+          <a:xfrm>
+            <a:off x="9782617" y="1938528"/>
+            <a:ext cx="1531254" cy="420624"/>
+          </a:xfrm>
+          <a:prstGeom prst="rect">
+            <a:avLst/>
+          </a:prstGeom>
+          <a:noFill/>
+          <a:ln/>
+        </p:spPr>
+        <p:txBody>
+          <a:bodyPr wrap="square" lIns="0" tIns="0" rIns="0" bIns="0" rtlCol="0" anchor="ctr"/>
+          <a:lstStyle/>
+          <a:p>
+            <a:pPr indent="0" marL="0">
+              <a:lnSpc>
+                <a:spcPct val="105000"/>
+              </a:lnSpc>
+              <a:buNone/>
+            </a:pPr>
+            <a:r>
+              <a:rPr lang="en-US" sz="1400" b="1" dirty="0">
+                <a:solidFill>
+                  <a:srgbClr val="FFFFFF"/>
+                </a:solidFill>
+                <a:latin typeface="Calibri" pitchFamily="34" charset="0"/>
+                <a:ea typeface="Calibri" pitchFamily="34" charset="-122"/>
+                <a:cs typeface="Calibri" pitchFamily="34" charset="-120"/>
+              </a:rPr>
+              <a:t>검증 · 완료</a:t>
+            </a:r>
+            <a:endParaRPr lang="en-US" sz="1400" dirty="0"/>
+          </a:p>
+        </p:txBody>
+      </p:sp>
+      <p:sp>
+        <p:nvSpPr>
+          <p:cNvPr id="25" name="Text 23"/>
+          <p:cNvSpPr txBox="1"/>
+          <p:nvPr/>
+        </p:nvSpPr>
+        <p:spPr>
+          <a:xfrm>
+            <a:off x="640080" y="2761488"/>
+            <a:ext cx="5486400" cy="237744"/>
+          </a:xfrm>
+          <a:prstGeom prst="rect">
+            <a:avLst/>
+          </a:prstGeom>
+          <a:noFill/>
+          <a:ln/>
+        </p:spPr>
+        <p:txBody>
+          <a:bodyPr wrap="square" lIns="0" tIns="0" rIns="0" bIns="0" rtlCol="0" anchor="ctr"/>
+          <a:lstStyle/>
+          <a:p>
+            <a:pPr indent="0" marL="0">
+              <a:buNone/>
+            </a:pPr>
+            <a:r>
+              <a:rPr lang="en-US" sz="1050" b="1" spc="60" kern="0" dirty="0">
+                <a:solidFill>
+                  <a:srgbClr val="2F6BFF"/>
+                </a:solidFill>
+                <a:latin typeface="Calibri" pitchFamily="34" charset="0"/>
+                <a:ea typeface="Calibri" pitchFamily="34" charset="-122"/>
+                <a:cs typeface="Calibri" pitchFamily="34" charset="-120"/>
+              </a:rPr>
+              <a:t>그래서 무엇이 나오는가</a:t>
+            </a:r>
+            <a:endParaRPr lang="en-US" sz="1050" dirty="0"/>
+          </a:p>
+        </p:txBody>
+      </p:sp>
+      <p:sp>
+        <p:nvSpPr>
           <p:cNvPr id="26" name="Text 24"/>
           <p:cNvSpPr txBox="1"/>
           <p:nvPr/>
         </p:nvSpPr>
         <p:spPr>
           <a:xfrm>
-            <a:off x="9782617" y="1920240"/>
-            <a:ext cx="1531254" cy="256032"/>
-          </a:xfrm>
-          <a:prstGeom prst="rect">
-            <a:avLst/>
-          </a:prstGeom>
-          <a:noFill/>
-          <a:ln/>
-        </p:spPr>
-        <p:txBody>
-          <a:bodyPr wrap="square" lIns="0" tIns="0" rIns="0" bIns="0" rtlCol="0" anchor="ctr"/>
-          <a:lstStyle/>
-          <a:p>
-            <a:pPr indent="0" marL="0">
-              <a:buNone/>
-            </a:pPr>
-            <a:r>
-              <a:rPr lang="en-US" sz="1100" b="1" dirty="0">
-                <a:solidFill>
-                  <a:srgbClr val="9FB8FF"/>
-                </a:solidFill>
-                <a:latin typeface="Calibri" pitchFamily="34" charset="0"/>
-                <a:ea typeface="Calibri" pitchFamily="34" charset="-122"/>
-                <a:cs typeface="Calibri" pitchFamily="34" charset="-120"/>
-              </a:rPr>
-              <a:t>05</a:t>
-            </a:r>
-            <a:endParaRPr lang="en-US" sz="1100" dirty="0"/>
-          </a:p>
-        </p:txBody>
-      </p:sp>
-      <p:sp>
-        <p:nvSpPr>
-          <p:cNvPr id="27" name="Text 25"/>
-          <p:cNvSpPr txBox="1"/>
-          <p:nvPr/>
-        </p:nvSpPr>
-        <p:spPr>
-          <a:xfrm>
-            <a:off x="9782617" y="2322576"/>
-            <a:ext cx="1531254" cy="603504"/>
-          </a:xfrm>
-          <a:prstGeom prst="rect">
-            <a:avLst/>
-          </a:prstGeom>
-          <a:noFill/>
-          <a:ln/>
-        </p:spPr>
-        <p:txBody>
-          <a:bodyPr wrap="square" lIns="0" tIns="0" rIns="0" bIns="0" rtlCol="0" anchor="ctr"/>
-          <a:lstStyle/>
-          <a:p>
-            <a:pPr indent="0" marL="0">
-              <a:lnSpc>
-                <a:spcPct val="110000"/>
-              </a:lnSpc>
-              <a:buNone/>
-            </a:pPr>
-            <a:r>
-              <a:rPr lang="en-US" sz="1450" b="1" dirty="0">
-                <a:solidFill>
-                  <a:srgbClr val="FFFFFF"/>
-                </a:solidFill>
-                <a:latin typeface="Calibri" pitchFamily="34" charset="0"/>
-                <a:ea typeface="Calibri" pitchFamily="34" charset="-122"/>
-                <a:cs typeface="Calibri" pitchFamily="34" charset="-120"/>
-              </a:rPr>
-              <a:t>검증 · 완료</a:t>
-            </a:r>
-            <a:endParaRPr lang="en-US" sz="1450" dirty="0"/>
-          </a:p>
-        </p:txBody>
-      </p:sp>
-      <p:sp>
-        <p:nvSpPr>
-          <p:cNvPr id="28" name="Text 26"/>
-          <p:cNvSpPr txBox="1"/>
-          <p:nvPr/>
-        </p:nvSpPr>
-        <p:spPr>
-          <a:xfrm>
-            <a:off x="9782617" y="2999232"/>
-            <a:ext cx="1531254" cy="457200"/>
-          </a:xfrm>
-          <a:prstGeom prst="rect">
-            <a:avLst/>
-          </a:prstGeom>
-          <a:noFill/>
-          <a:ln/>
-        </p:spPr>
-        <p:txBody>
-          <a:bodyPr wrap="square" lIns="0" tIns="0" rIns="0" bIns="0" rtlCol="0" anchor="ctr"/>
-          <a:lstStyle/>
-          <a:p>
-            <a:pPr indent="0" marL="0">
-              <a:lnSpc>
-                <a:spcPct val="120000"/>
-              </a:lnSpc>
-              <a:buNone/>
-            </a:pPr>
-            <a:r>
-              <a:rPr lang="en-US" sz="1100" dirty="0">
-                <a:solidFill>
-                  <a:srgbClr val="AFBFD6"/>
-                </a:solidFill>
-                <a:latin typeface="Calibri" pitchFamily="34" charset="0"/>
-                <a:ea typeface="Calibri" pitchFamily="34" charset="-122"/>
-                <a:cs typeface="Calibri" pitchFamily="34" charset="-120"/>
-              </a:rPr>
-              <a:t>테스트 · 리뷰 · 브랜치</a:t>
-            </a:r>
-            <a:endParaRPr lang="en-US" sz="1100" dirty="0"/>
-          </a:p>
-        </p:txBody>
-      </p:sp>
-      <p:sp>
-        <p:nvSpPr>
-          <p:cNvPr id="29" name="Shape 27"/>
+            <a:off x="640080" y="2487168"/>
+            <a:ext cx="2006742" cy="237744"/>
+          </a:xfrm>
+          <a:prstGeom prst="rect">
+            <a:avLst/>
+          </a:prstGeom>
+          <a:noFill/>
+          <a:ln/>
+        </p:spPr>
+        <p:txBody>
+          <a:bodyPr wrap="square" lIns="0" tIns="0" rIns="0" bIns="0" rtlCol="0" anchor="ctr"/>
+          <a:lstStyle/>
+          <a:p>
+            <a:pPr algn="ctr" indent="0" marL="0">
+              <a:buNone/>
+            </a:pPr>
+            <a:r>
+              <a:rPr lang="en-US" sz="1300" b="1" dirty="0">
+                <a:solidFill>
+                  <a:srgbClr val="D3E0FF"/>
+                </a:solidFill>
+                <a:latin typeface="Calibri" pitchFamily="34" charset="0"/>
+                <a:ea typeface="Calibri" pitchFamily="34" charset="-122"/>
+                <a:cs typeface="Calibri" pitchFamily="34" charset="-120"/>
+              </a:rPr>
+              <a:t>↓</a:t>
+            </a:r>
+            <a:endParaRPr lang="en-US" sz="1300" dirty="0"/>
+          </a:p>
+        </p:txBody>
+      </p:sp>
+      <p:sp>
+        <p:nvSpPr>
+          <p:cNvPr id="27" name="Shape 25"/>
           <p:cNvSpPr/>
           <p:nvPr/>
         </p:nvSpPr>
         <p:spPr>
           <a:xfrm>
-            <a:off x="640080" y="4279392"/>
-            <a:ext cx="10911535" cy="932688"/>
+            <a:off x="640080" y="3072384"/>
+            <a:ext cx="2006742" cy="1316736"/>
           </a:xfrm>
           <a:prstGeom prst="roundRect">
             <a:avLst>
-              <a:gd name="adj" fmla="val 5882"/>
+              <a:gd name="adj" fmla="val 4861"/>
+            </a:avLst>
+          </a:prstGeom>
+          <a:solidFill>
+            <a:srgbClr val="FFFFFF"/>
+          </a:solidFill>
+          <a:ln w="12700">
+            <a:solidFill>
+              <a:srgbClr val="D3E0FF"/>
+            </a:solidFill>
+            <a:prstDash val="solid"/>
+          </a:ln>
+        </p:spPr>
+      </p:sp>
+      <p:sp>
+        <p:nvSpPr>
+          <p:cNvPr id="28" name="Text 26"/>
+          <p:cNvSpPr txBox="1"/>
+          <p:nvPr/>
+        </p:nvSpPr>
+        <p:spPr>
+          <a:xfrm>
+            <a:off x="877824" y="3291840"/>
+            <a:ext cx="1531254" cy="877824"/>
+          </a:xfrm>
+          <a:prstGeom prst="rect">
+            <a:avLst/>
+          </a:prstGeom>
+          <a:noFill/>
+          <a:ln/>
+        </p:spPr>
+        <p:txBody>
+          <a:bodyPr wrap="square" lIns="0" tIns="0" rIns="0" bIns="0" rtlCol="0" anchor="ctr"/>
+          <a:lstStyle/>
+          <a:p>
+            <a:pPr indent="0" marL="0">
+              <a:lnSpc>
+                <a:spcPct val="130000"/>
+              </a:lnSpc>
+              <a:buNone/>
+            </a:pPr>
+            <a:r>
+              <a:rPr lang="en-US" sz="1150" dirty="0">
+                <a:solidFill>
+                  <a:srgbClr val="27374F"/>
+                </a:solidFill>
+                <a:latin typeface="Calibri" pitchFamily="34" charset="0"/>
+                <a:ea typeface="Calibri" pitchFamily="34" charset="-122"/>
+                <a:cs typeface="Calibri" pitchFamily="34" charset="-120"/>
+              </a:rPr>
+              <a:t>만들고 싶은 것 한 문장</a:t>
+            </a:r>
+            <a:endParaRPr lang="en-US" sz="1150" dirty="0"/>
+          </a:p>
+        </p:txBody>
+      </p:sp>
+      <p:sp>
+        <p:nvSpPr>
+          <p:cNvPr id="29" name="Text 27"/>
+          <p:cNvSpPr txBox="1"/>
+          <p:nvPr/>
+        </p:nvSpPr>
+        <p:spPr>
+          <a:xfrm>
+            <a:off x="2866278" y="2487168"/>
+            <a:ext cx="2006742" cy="237744"/>
+          </a:xfrm>
+          <a:prstGeom prst="rect">
+            <a:avLst/>
+          </a:prstGeom>
+          <a:noFill/>
+          <a:ln/>
+        </p:spPr>
+        <p:txBody>
+          <a:bodyPr wrap="square" lIns="0" tIns="0" rIns="0" bIns="0" rtlCol="0" anchor="ctr"/>
+          <a:lstStyle/>
+          <a:p>
+            <a:pPr algn="ctr" indent="0" marL="0">
+              <a:buNone/>
+            </a:pPr>
+            <a:r>
+              <a:rPr lang="en-US" sz="1300" b="1" dirty="0">
+                <a:solidFill>
+                  <a:srgbClr val="D3E0FF"/>
+                </a:solidFill>
+                <a:latin typeface="Calibri" pitchFamily="34" charset="0"/>
+                <a:ea typeface="Calibri" pitchFamily="34" charset="-122"/>
+                <a:cs typeface="Calibri" pitchFamily="34" charset="-120"/>
+              </a:rPr>
+              <a:t>↓</a:t>
+            </a:r>
+            <a:endParaRPr lang="en-US" sz="1300" dirty="0"/>
+          </a:p>
+        </p:txBody>
+      </p:sp>
+      <p:sp>
+        <p:nvSpPr>
+          <p:cNvPr id="30" name="Shape 28"/>
+          <p:cNvSpPr/>
+          <p:nvPr/>
+        </p:nvSpPr>
+        <p:spPr>
+          <a:xfrm>
+            <a:off x="2866278" y="3072384"/>
+            <a:ext cx="2006742" cy="1316736"/>
+          </a:xfrm>
+          <a:prstGeom prst="roundRect">
+            <a:avLst>
+              <a:gd name="adj" fmla="val 4861"/>
+            </a:avLst>
+          </a:prstGeom>
+          <a:solidFill>
+            <a:srgbClr val="FFFFFF"/>
+          </a:solidFill>
+          <a:ln w="12700">
+            <a:solidFill>
+              <a:srgbClr val="D3E0FF"/>
+            </a:solidFill>
+            <a:prstDash val="solid"/>
+          </a:ln>
+        </p:spPr>
+      </p:sp>
+      <p:sp>
+        <p:nvSpPr>
+          <p:cNvPr id="31" name="Text 29"/>
+          <p:cNvSpPr txBox="1"/>
+          <p:nvPr/>
+        </p:nvSpPr>
+        <p:spPr>
+          <a:xfrm>
+            <a:off x="3104022" y="3291840"/>
+            <a:ext cx="1531254" cy="877824"/>
+          </a:xfrm>
+          <a:prstGeom prst="rect">
+            <a:avLst/>
+          </a:prstGeom>
+          <a:noFill/>
+          <a:ln/>
+        </p:spPr>
+        <p:txBody>
+          <a:bodyPr wrap="square" lIns="0" tIns="0" rIns="0" bIns="0" rtlCol="0" anchor="ctr"/>
+          <a:lstStyle/>
+          <a:p>
+            <a:pPr indent="0" marL="0">
+              <a:lnSpc>
+                <a:spcPct val="130000"/>
+              </a:lnSpc>
+              <a:buNone/>
+            </a:pPr>
+            <a:r>
+              <a:rPr lang="en-US" sz="1150" dirty="0">
+                <a:solidFill>
+                  <a:srgbClr val="27374F"/>
+                </a:solidFill>
+                <a:latin typeface="Calibri" pitchFamily="34" charset="0"/>
+                <a:ea typeface="Calibri" pitchFamily="34" charset="-122"/>
+                <a:cs typeface="Calibri" pitchFamily="34" charset="-120"/>
+              </a:rPr>
+              <a:t>확정된 요구사항과 설계</a:t>
+            </a:r>
+            <a:endParaRPr lang="en-US" sz="1150" dirty="0"/>
+          </a:p>
+        </p:txBody>
+      </p:sp>
+      <p:sp>
+        <p:nvSpPr>
+          <p:cNvPr id="32" name="Text 30"/>
+          <p:cNvSpPr txBox="1"/>
+          <p:nvPr/>
+        </p:nvSpPr>
+        <p:spPr>
+          <a:xfrm>
+            <a:off x="5092476" y="2487168"/>
+            <a:ext cx="2006742" cy="237744"/>
+          </a:xfrm>
+          <a:prstGeom prst="rect">
+            <a:avLst/>
+          </a:prstGeom>
+          <a:noFill/>
+          <a:ln/>
+        </p:spPr>
+        <p:txBody>
+          <a:bodyPr wrap="square" lIns="0" tIns="0" rIns="0" bIns="0" rtlCol="0" anchor="ctr"/>
+          <a:lstStyle/>
+          <a:p>
+            <a:pPr algn="ctr" indent="0" marL="0">
+              <a:buNone/>
+            </a:pPr>
+            <a:r>
+              <a:rPr lang="en-US" sz="1300" b="1" dirty="0">
+                <a:solidFill>
+                  <a:srgbClr val="D3E0FF"/>
+                </a:solidFill>
+                <a:latin typeface="Calibri" pitchFamily="34" charset="0"/>
+                <a:ea typeface="Calibri" pitchFamily="34" charset="-122"/>
+                <a:cs typeface="Calibri" pitchFamily="34" charset="-120"/>
+              </a:rPr>
+              <a:t>↓</a:t>
+            </a:r>
+            <a:endParaRPr lang="en-US" sz="1300" dirty="0"/>
+          </a:p>
+        </p:txBody>
+      </p:sp>
+      <p:sp>
+        <p:nvSpPr>
+          <p:cNvPr id="33" name="Shape 31"/>
+          <p:cNvSpPr/>
+          <p:nvPr/>
+        </p:nvSpPr>
+        <p:spPr>
+          <a:xfrm>
+            <a:off x="5092476" y="3072384"/>
+            <a:ext cx="2006742" cy="1316736"/>
+          </a:xfrm>
+          <a:prstGeom prst="roundRect">
+            <a:avLst>
+              <a:gd name="adj" fmla="val 4861"/>
+            </a:avLst>
+          </a:prstGeom>
+          <a:solidFill>
+            <a:srgbClr val="FFFFFF"/>
+          </a:solidFill>
+          <a:ln w="12700">
+            <a:solidFill>
+              <a:srgbClr val="D3E0FF"/>
+            </a:solidFill>
+            <a:prstDash val="solid"/>
+          </a:ln>
+        </p:spPr>
+      </p:sp>
+      <p:sp>
+        <p:nvSpPr>
+          <p:cNvPr id="34" name="Text 32"/>
+          <p:cNvSpPr txBox="1"/>
+          <p:nvPr/>
+        </p:nvSpPr>
+        <p:spPr>
+          <a:xfrm>
+            <a:off x="5330220" y="3291840"/>
+            <a:ext cx="1531254" cy="877824"/>
+          </a:xfrm>
+          <a:prstGeom prst="rect">
+            <a:avLst/>
+          </a:prstGeom>
+          <a:noFill/>
+          <a:ln/>
+        </p:spPr>
+        <p:txBody>
+          <a:bodyPr wrap="square" lIns="0" tIns="0" rIns="0" bIns="0" rtlCol="0" anchor="ctr"/>
+          <a:lstStyle/>
+          <a:p>
+            <a:pPr indent="0" marL="0">
+              <a:lnSpc>
+                <a:spcPct val="130000"/>
+              </a:lnSpc>
+              <a:buNone/>
+            </a:pPr>
+            <a:r>
+              <a:rPr lang="en-US" sz="1150" dirty="0">
+                <a:solidFill>
+                  <a:srgbClr val="27374F"/>
+                </a:solidFill>
+                <a:latin typeface="Calibri" pitchFamily="34" charset="0"/>
+                <a:ea typeface="Calibri" pitchFamily="34" charset="-122"/>
+                <a:cs typeface="Calibri" pitchFamily="34" charset="-120"/>
+              </a:rPr>
+              <a:t>구현 계획서</a:t>
+            </a:r>
+            <a:endParaRPr lang="en-US" sz="1150" dirty="0"/>
+          </a:p>
+          <a:p>
+            <a:pPr indent="0" marL="0">
+              <a:lnSpc>
+                <a:spcPct val="130000"/>
+              </a:lnSpc>
+              <a:buNone/>
+            </a:pPr>
+            <a:r>
+              <a:rPr lang="en-US" sz="1150" dirty="0">
+                <a:solidFill>
+                  <a:srgbClr val="27374F"/>
+                </a:solidFill>
+                <a:latin typeface="Calibri" pitchFamily="34" charset="0"/>
+                <a:ea typeface="Calibri" pitchFamily="34" charset="-122"/>
+                <a:cs typeface="Calibri" pitchFamily="34" charset="-120"/>
+              </a:rPr>
+              <a:t>(파일·테스트·순서)</a:t>
+            </a:r>
+            <a:endParaRPr lang="en-US" sz="1150" dirty="0"/>
+          </a:p>
+        </p:txBody>
+      </p:sp>
+      <p:sp>
+        <p:nvSpPr>
+          <p:cNvPr id="35" name="Text 33"/>
+          <p:cNvSpPr txBox="1"/>
+          <p:nvPr/>
+        </p:nvSpPr>
+        <p:spPr>
+          <a:xfrm>
+            <a:off x="7318675" y="2487168"/>
+            <a:ext cx="2006742" cy="237744"/>
+          </a:xfrm>
+          <a:prstGeom prst="rect">
+            <a:avLst/>
+          </a:prstGeom>
+          <a:noFill/>
+          <a:ln/>
+        </p:spPr>
+        <p:txBody>
+          <a:bodyPr wrap="square" lIns="0" tIns="0" rIns="0" bIns="0" rtlCol="0" anchor="ctr"/>
+          <a:lstStyle/>
+          <a:p>
+            <a:pPr algn="ctr" indent="0" marL="0">
+              <a:buNone/>
+            </a:pPr>
+            <a:r>
+              <a:rPr lang="en-US" sz="1300" b="1" dirty="0">
+                <a:solidFill>
+                  <a:srgbClr val="D3E0FF"/>
+                </a:solidFill>
+                <a:latin typeface="Calibri" pitchFamily="34" charset="0"/>
+                <a:ea typeface="Calibri" pitchFamily="34" charset="-122"/>
+                <a:cs typeface="Calibri" pitchFamily="34" charset="-120"/>
+              </a:rPr>
+              <a:t>↓</a:t>
+            </a:r>
+            <a:endParaRPr lang="en-US" sz="1300" dirty="0"/>
+          </a:p>
+        </p:txBody>
+      </p:sp>
+      <p:sp>
+        <p:nvSpPr>
+          <p:cNvPr id="36" name="Shape 34"/>
+          <p:cNvSpPr/>
+          <p:nvPr/>
+        </p:nvSpPr>
+        <p:spPr>
+          <a:xfrm>
+            <a:off x="7318675" y="3072384"/>
+            <a:ext cx="2006742" cy="1316736"/>
+          </a:xfrm>
+          <a:prstGeom prst="roundRect">
+            <a:avLst>
+              <a:gd name="adj" fmla="val 4861"/>
+            </a:avLst>
+          </a:prstGeom>
+          <a:solidFill>
+            <a:srgbClr val="FFFFFF"/>
+          </a:solidFill>
+          <a:ln w="12700">
+            <a:solidFill>
+              <a:srgbClr val="D3E0FF"/>
+            </a:solidFill>
+            <a:prstDash val="solid"/>
+          </a:ln>
+        </p:spPr>
+      </p:sp>
+      <p:sp>
+        <p:nvSpPr>
+          <p:cNvPr id="37" name="Text 35"/>
+          <p:cNvSpPr txBox="1"/>
+          <p:nvPr/>
+        </p:nvSpPr>
+        <p:spPr>
+          <a:xfrm>
+            <a:off x="7556419" y="3291840"/>
+            <a:ext cx="1531254" cy="877824"/>
+          </a:xfrm>
+          <a:prstGeom prst="rect">
+            <a:avLst/>
+          </a:prstGeom>
+          <a:noFill/>
+          <a:ln/>
+        </p:spPr>
+        <p:txBody>
+          <a:bodyPr wrap="square" lIns="0" tIns="0" rIns="0" bIns="0" rtlCol="0" anchor="ctr"/>
+          <a:lstStyle/>
+          <a:p>
+            <a:pPr indent="0" marL="0">
+              <a:lnSpc>
+                <a:spcPct val="130000"/>
+              </a:lnSpc>
+              <a:buNone/>
+            </a:pPr>
+            <a:r>
+              <a:rPr lang="en-US" sz="1150" dirty="0">
+                <a:solidFill>
+                  <a:srgbClr val="27374F"/>
+                </a:solidFill>
+                <a:latin typeface="Calibri" pitchFamily="34" charset="0"/>
+                <a:ea typeface="Calibri" pitchFamily="34" charset="-122"/>
+                <a:cs typeface="Calibri" pitchFamily="34" charset="-120"/>
+              </a:rPr>
+              <a:t>테스트를 통과한 코드</a:t>
+            </a:r>
+            <a:endParaRPr lang="en-US" sz="1150" dirty="0"/>
+          </a:p>
+        </p:txBody>
+      </p:sp>
+      <p:sp>
+        <p:nvSpPr>
+          <p:cNvPr id="38" name="Text 36"/>
+          <p:cNvSpPr txBox="1"/>
+          <p:nvPr/>
+        </p:nvSpPr>
+        <p:spPr>
+          <a:xfrm>
+            <a:off x="9544873" y="2487168"/>
+            <a:ext cx="2006742" cy="237744"/>
+          </a:xfrm>
+          <a:prstGeom prst="rect">
+            <a:avLst/>
+          </a:prstGeom>
+          <a:noFill/>
+          <a:ln/>
+        </p:spPr>
+        <p:txBody>
+          <a:bodyPr wrap="square" lIns="0" tIns="0" rIns="0" bIns="0" rtlCol="0" anchor="ctr"/>
+          <a:lstStyle/>
+          <a:p>
+            <a:pPr algn="ctr" indent="0" marL="0">
+              <a:buNone/>
+            </a:pPr>
+            <a:r>
+              <a:rPr lang="en-US" sz="1300" b="1" dirty="0">
+                <a:solidFill>
+                  <a:srgbClr val="D3E0FF"/>
+                </a:solidFill>
+                <a:latin typeface="Calibri" pitchFamily="34" charset="0"/>
+                <a:ea typeface="Calibri" pitchFamily="34" charset="-122"/>
+                <a:cs typeface="Calibri" pitchFamily="34" charset="-120"/>
+              </a:rPr>
+              <a:t>↓</a:t>
+            </a:r>
+            <a:endParaRPr lang="en-US" sz="1300" dirty="0"/>
+          </a:p>
+        </p:txBody>
+      </p:sp>
+      <p:sp>
+        <p:nvSpPr>
+          <p:cNvPr id="39" name="Shape 37"/>
+          <p:cNvSpPr/>
+          <p:nvPr/>
+        </p:nvSpPr>
+        <p:spPr>
+          <a:xfrm>
+            <a:off x="9544873" y="3072384"/>
+            <a:ext cx="2006742" cy="1316736"/>
+          </a:xfrm>
+          <a:prstGeom prst="roundRect">
+            <a:avLst>
+              <a:gd name="adj" fmla="val 4861"/>
+            </a:avLst>
+          </a:prstGeom>
+          <a:solidFill>
+            <a:srgbClr val="FFFFFF"/>
+          </a:solidFill>
+          <a:ln w="12700">
+            <a:solidFill>
+              <a:srgbClr val="D3E0FF"/>
+            </a:solidFill>
+            <a:prstDash val="solid"/>
+          </a:ln>
+        </p:spPr>
+      </p:sp>
+      <p:sp>
+        <p:nvSpPr>
+          <p:cNvPr id="40" name="Text 38"/>
+          <p:cNvSpPr txBox="1"/>
+          <p:nvPr/>
+        </p:nvSpPr>
+        <p:spPr>
+          <a:xfrm>
+            <a:off x="9782617" y="3291840"/>
+            <a:ext cx="1531254" cy="877824"/>
+          </a:xfrm>
+          <a:prstGeom prst="rect">
+            <a:avLst/>
+          </a:prstGeom>
+          <a:noFill/>
+          <a:ln/>
+        </p:spPr>
+        <p:txBody>
+          <a:bodyPr wrap="square" lIns="0" tIns="0" rIns="0" bIns="0" rtlCol="0" anchor="ctr"/>
+          <a:lstStyle/>
+          <a:p>
+            <a:pPr indent="0" marL="0">
+              <a:lnSpc>
+                <a:spcPct val="130000"/>
+              </a:lnSpc>
+              <a:buNone/>
+            </a:pPr>
+            <a:r>
+              <a:rPr lang="en-US" sz="1150" dirty="0">
+                <a:solidFill>
+                  <a:srgbClr val="27374F"/>
+                </a:solidFill>
+                <a:latin typeface="Calibri" pitchFamily="34" charset="0"/>
+                <a:ea typeface="Calibri" pitchFamily="34" charset="-122"/>
+                <a:cs typeface="Calibri" pitchFamily="34" charset="-120"/>
+              </a:rPr>
+              <a:t>테스트 기록과</a:t>
+            </a:r>
+            <a:endParaRPr lang="en-US" sz="1150" dirty="0"/>
+          </a:p>
+          <a:p>
+            <a:pPr indent="0" marL="0">
+              <a:lnSpc>
+                <a:spcPct val="130000"/>
+              </a:lnSpc>
+              <a:buNone/>
+            </a:pPr>
+            <a:r>
+              <a:rPr lang="en-US" sz="1150" dirty="0">
+                <a:solidFill>
+                  <a:srgbClr val="27374F"/>
+                </a:solidFill>
+                <a:latin typeface="Calibri" pitchFamily="34" charset="0"/>
+                <a:ea typeface="Calibri" pitchFamily="34" charset="-122"/>
+                <a:cs typeface="Calibri" pitchFamily="34" charset="-120"/>
+              </a:rPr>
+              <a:t>정리된 브랜치</a:t>
+            </a:r>
+            <a:endParaRPr lang="en-US" sz="1150" dirty="0"/>
+          </a:p>
+        </p:txBody>
+      </p:sp>
+      <p:sp>
+        <p:nvSpPr>
+          <p:cNvPr id="41" name="Shape 39"/>
+          <p:cNvSpPr/>
+          <p:nvPr/>
+        </p:nvSpPr>
+        <p:spPr>
+          <a:xfrm>
+            <a:off x="640080" y="4700016"/>
+            <a:ext cx="10911535" cy="969264"/>
+          </a:xfrm>
+          <a:prstGeom prst="roundRect">
+            <a:avLst>
+              <a:gd name="adj" fmla="val 5660"/>
             </a:avLst>
           </a:prstGeom>
           <a:solidFill>
@@ -15404,103 +15852,36 @@
       </p:sp>
       <p:sp>
         <p:nvSpPr>
-          <p:cNvPr id="30" name="Text 28"/>
-          <p:cNvSpPr txBox="1"/>
-          <p:nvPr/>
-        </p:nvSpPr>
-        <p:spPr>
-          <a:xfrm>
-            <a:off x="914400" y="4279392"/>
-            <a:ext cx="10362895" cy="932688"/>
-          </a:xfrm>
-          <a:prstGeom prst="rect">
-            <a:avLst/>
-          </a:prstGeom>
-          <a:noFill/>
-          <a:ln/>
-        </p:spPr>
-        <p:txBody>
-          <a:bodyPr wrap="square" lIns="0" tIns="0" rIns="0" bIns="0" rtlCol="0" anchor="ctr"/>
-          <a:lstStyle/>
-          <a:p>
-            <a:pPr algn="ctr" indent="0" marL="0">
-              <a:buNone/>
-            </a:pPr>
-            <a:r>
-              <a:rPr lang="en-US" sz="1300" dirty="0">
-                <a:solidFill>
-                  <a:srgbClr val="8A6A44"/>
-                </a:solidFill>
-                <a:latin typeface="Calibri" pitchFamily="34" charset="0"/>
-                <a:ea typeface="Calibri" pitchFamily="34" charset="-122"/>
-                <a:cs typeface="Calibri" pitchFamily="34" charset="-120"/>
-              </a:rPr>
-              <a:t>작업 중 오류가 생기면  </a:t>
-            </a:r>
-            <a:pPr algn="ctr" indent="0" marL="0">
-              <a:buNone/>
-            </a:pPr>
-            <a:r>
-              <a:rPr lang="en-US" sz="1300" b="1" dirty="0">
-                <a:solidFill>
-                  <a:srgbClr val="B4651F"/>
-                </a:solidFill>
-                <a:latin typeface="Calibri" pitchFamily="34" charset="0"/>
-                <a:ea typeface="Calibri" pitchFamily="34" charset="-122"/>
-                <a:cs typeface="Calibri" pitchFamily="34" charset="-120"/>
-              </a:rPr>
-              <a:t>Systematic Debugging</a:t>
-            </a:r>
-            <a:pPr algn="ctr" indent="0" marL="0">
-              <a:buNone/>
-            </a:pPr>
-            <a:r>
-              <a:rPr lang="en-US" sz="1300" dirty="0">
-                <a:solidFill>
-                  <a:srgbClr val="8A6A44"/>
-                </a:solidFill>
-                <a:latin typeface="Calibri" pitchFamily="34" charset="0"/>
-                <a:ea typeface="Calibri" pitchFamily="34" charset="-122"/>
-                <a:cs typeface="Calibri" pitchFamily="34" charset="-120"/>
-              </a:rPr>
-              <a:t>  으로 원인부터 찾은 뒤 다시 흐름에 복귀합니다.</a:t>
-            </a:r>
-            <a:endParaRPr lang="en-US" sz="1300" dirty="0"/>
-          </a:p>
-        </p:txBody>
-      </p:sp>
-      <p:sp>
-        <p:nvSpPr>
-          <p:cNvPr id="31" name="Shape 29"/>
+          <p:cNvPr id="42" name="Shape 40"/>
           <p:cNvSpPr/>
           <p:nvPr/>
         </p:nvSpPr>
         <p:spPr>
           <a:xfrm>
-            <a:off x="640080" y="5431536"/>
-            <a:ext cx="10911535" cy="566928"/>
+            <a:off x="950976" y="5010912"/>
+            <a:ext cx="1133856" cy="347472"/>
           </a:xfrm>
           <a:prstGeom prst="roundRect">
             <a:avLst>
-              <a:gd name="adj" fmla="val 9677"/>
+              <a:gd name="adj" fmla="val 50000"/>
             </a:avLst>
           </a:prstGeom>
           <a:solidFill>
-            <a:srgbClr val="EEF3FF"/>
+            <a:srgbClr val="F2994A"/>
           </a:solidFill>
           <a:ln/>
         </p:spPr>
       </p:sp>
       <p:sp>
         <p:nvSpPr>
-          <p:cNvPr id="32" name="Text 30"/>
-          <p:cNvSpPr txBox="1"/>
-          <p:nvPr/>
-        </p:nvSpPr>
-        <p:spPr>
-          <a:xfrm>
-            <a:off x="914400" y="5431536"/>
-            <a:ext cx="10362895" cy="566928"/>
+          <p:cNvPr id="43" name="Text 41"/>
+          <p:cNvSpPr txBox="1"/>
+          <p:nvPr/>
+        </p:nvSpPr>
+        <p:spPr>
+          <a:xfrm>
+            <a:off x="950976" y="5010912"/>
+            <a:ext cx="1133856" cy="347472"/>
           </a:xfrm>
           <a:prstGeom prst="rect">
             <a:avLst/>
@@ -15516,17 +15897,109 @@
               <a:buNone/>
             </a:pPr>
             <a:r>
-              <a:rPr lang="en-US" sz="1350" b="1" dirty="0">
-                <a:solidFill>
-                  <a:srgbClr val="1E4FD1"/>
-                </a:solidFill>
-                <a:latin typeface="Calibri" pitchFamily="34" charset="0"/>
-                <a:ea typeface="Calibri" pitchFamily="34" charset="-122"/>
-                <a:cs typeface="Calibri" pitchFamily="34" charset="-120"/>
-              </a:rPr>
-              <a:t>이해 → 계획 → 구현 → 검증. 각 단계의 결과가 다음 단계의 입력이 됩니다.</a:t>
-            </a:r>
-            <a:endParaRPr lang="en-US" sz="1350" dirty="0"/>
+              <a:rPr lang="en-US" sz="1050" b="1" dirty="0">
+                <a:solidFill>
+                  <a:srgbClr val="FFFFFF"/>
+                </a:solidFill>
+                <a:latin typeface="Calibri" pitchFamily="34" charset="0"/>
+                <a:ea typeface="Calibri" pitchFamily="34" charset="-122"/>
+                <a:cs typeface="Calibri" pitchFamily="34" charset="-120"/>
+              </a:rPr>
+              <a:t>오류 발생 시</a:t>
+            </a:r>
+            <a:endParaRPr lang="en-US" sz="1050" dirty="0"/>
+          </a:p>
+        </p:txBody>
+      </p:sp>
+      <p:sp>
+        <p:nvSpPr>
+          <p:cNvPr id="44" name="Text 42"/>
+          <p:cNvSpPr txBox="1"/>
+          <p:nvPr/>
+        </p:nvSpPr>
+        <p:spPr>
+          <a:xfrm>
+            <a:off x="2249424" y="4700016"/>
+            <a:ext cx="8991295" cy="969264"/>
+          </a:xfrm>
+          <a:prstGeom prst="rect">
+            <a:avLst/>
+          </a:prstGeom>
+          <a:noFill/>
+          <a:ln/>
+        </p:spPr>
+        <p:txBody>
+          <a:bodyPr wrap="square" lIns="0" tIns="0" rIns="0" bIns="0" rtlCol="0" anchor="ctr"/>
+          <a:lstStyle/>
+          <a:p>
+            <a:pPr indent="0" marL="0">
+              <a:buNone/>
+            </a:pPr>
+            <a:r>
+              <a:rPr lang="en-US" sz="1250" b="1" dirty="0">
+                <a:solidFill>
+                  <a:srgbClr val="A9541A"/>
+                </a:solidFill>
+                <a:latin typeface="Calibri" pitchFamily="34" charset="0"/>
+                <a:ea typeface="Calibri" pitchFamily="34" charset="-122"/>
+                <a:cs typeface="Calibri" pitchFamily="34" charset="-120"/>
+              </a:rPr>
+              <a:t>Systematic Debugging</a:t>
+            </a:r>
+            <a:pPr indent="0" marL="0">
+              <a:buNone/>
+            </a:pPr>
+            <a:r>
+              <a:rPr lang="en-US" sz="1250" dirty="0">
+                <a:solidFill>
+                  <a:srgbClr val="7E6242"/>
+                </a:solidFill>
+                <a:latin typeface="Calibri" pitchFamily="34" charset="0"/>
+                <a:ea typeface="Calibri" pitchFamily="34" charset="-122"/>
+                <a:cs typeface="Calibri" pitchFamily="34" charset="-120"/>
+              </a:rPr>
+              <a:t> 으로 재현 → 증거 → 원인을 확인한 뒤, 멈췄던 단계로 돌아갑니다.</a:t>
+            </a:r>
+            <a:endParaRPr lang="en-US" sz="1250" dirty="0"/>
+          </a:p>
+        </p:txBody>
+      </p:sp>
+      <p:sp>
+        <p:nvSpPr>
+          <p:cNvPr id="45" name="Text 43"/>
+          <p:cNvSpPr txBox="1"/>
+          <p:nvPr/>
+        </p:nvSpPr>
+        <p:spPr>
+          <a:xfrm>
+            <a:off x="640080" y="6382512"/>
+            <a:ext cx="10911535" cy="237744"/>
+          </a:xfrm>
+          <a:prstGeom prst="rect">
+            <a:avLst/>
+          </a:prstGeom>
+          <a:noFill/>
+          <a:ln/>
+        </p:spPr>
+        <p:txBody>
+          <a:bodyPr wrap="square" lIns="0" tIns="0" rIns="0" bIns="0" rtlCol="0" anchor="ctr"/>
+          <a:lstStyle/>
+          <a:p>
+            <a:pPr indent="0" marL="0">
+              <a:buNone/>
+            </a:pPr>
+            <a:r>
+              <a:rPr lang="en-US" sz="950" dirty="0">
+                <a:solidFill>
+                  <a:srgbClr val="8A94A6"/>
+                </a:solidFill>
+                <a:latin typeface="Calibri" pitchFamily="34" charset="0"/>
+                <a:ea typeface="Calibri" pitchFamily="34" charset="-122"/>
+                <a:cs typeface="Calibri" pitchFamily="34" charset="-120"/>
+              </a:rPr>
+              <a:t>Superpowers가 각 단계에 어떤 Skill을 쓰는지는 다음 장부터 살펴봅니다.</a:t>
+            </a:r>
+            <a:endParaRPr lang="en-US" sz="950" dirty="0"/>
           </a:p>
         </p:txBody>
       </p:sp>

</xml_diff>

<commit_message>
Name slide 7's stages in plain Korean, not skill jargon
"Brainstorming", "Writing Plans" and "TDD 구현" were the stage names, so a
beginner had to already know the vocabulary to read the flow at all.

- Lead each stage with what actually happens ("테스트 먼저, 구현 나중"), and
  demote the original skill name to a small second line so it still bridges
  to the skill slides
- Gloss TDD in the footer
- Spell out the debugging branch as 재현 -> 증거 -> 원인 instead of naming
  the skill and leaving the method implicit

Co-Authored-By: Claude Opus 5 <noreply@anthropic.com>
Claude-Session: https://claude.ai/code/session_015cu1phHjgbjCPUemRkBFgX
</commit_message>
<xml_diff>
--- a/presentation/Superpowers_Codex_10min.pptx
+++ b/presentation/Superpowers_Codex_10min.pptx
@@ -14507,7 +14507,7 @@
         </p:nvSpPr>
         <p:spPr>
           <a:xfrm>
-            <a:off x="640080" y="1225296"/>
+            <a:off x="640080" y="1188720"/>
             <a:ext cx="5486400" cy="237744"/>
           </a:xfrm>
           <a:prstGeom prst="rect">
@@ -14546,12 +14546,12 @@
         </p:nvSpPr>
         <p:spPr>
           <a:xfrm>
-            <a:off x="640080" y="1517904"/>
-            <a:ext cx="2006742" cy="950976"/>
+            <a:off x="640080" y="1481328"/>
+            <a:ext cx="2006742" cy="1207008"/>
           </a:xfrm>
           <a:prstGeom prst="roundRect">
             <a:avLst>
-              <a:gd name="adj" fmla="val 6731"/>
+              <a:gd name="adj" fmla="val 5303"/>
             </a:avLst>
           </a:prstGeom>
           <a:solidFill>
@@ -14568,24 +14568,24 @@
         </p:nvSpPr>
         <p:spPr>
           <a:xfrm>
-            <a:off x="877824" y="1664208"/>
-            <a:ext cx="1531254" cy="219456"/>
-          </a:xfrm>
-          <a:prstGeom prst="rect">
-            <a:avLst/>
-          </a:prstGeom>
-          <a:noFill/>
-          <a:ln/>
-        </p:spPr>
-        <p:txBody>
-          <a:bodyPr wrap="square" lIns="0" tIns="0" rIns="0" bIns="0" rtlCol="0" anchor="ctr"/>
-          <a:lstStyle/>
-          <a:p>
-            <a:pPr indent="0" marL="0">
-              <a:buNone/>
-            </a:pPr>
-            <a:r>
-              <a:rPr lang="en-US" sz="1050" b="1" dirty="0">
+            <a:off x="859536" y="1609344"/>
+            <a:ext cx="1567830" cy="201168"/>
+          </a:xfrm>
+          <a:prstGeom prst="rect">
+            <a:avLst/>
+          </a:prstGeom>
+          <a:noFill/>
+          <a:ln/>
+        </p:spPr>
+        <p:txBody>
+          <a:bodyPr wrap="square" lIns="0" tIns="0" rIns="0" bIns="0" rtlCol="0" anchor="ctr"/>
+          <a:lstStyle/>
+          <a:p>
+            <a:pPr indent="0" marL="0">
+              <a:buNone/>
+            </a:pPr>
+            <a:r>
+              <a:rPr lang="en-US" sz="1000" b="1" dirty="0">
                 <a:solidFill>
                   <a:srgbClr val="8A94A6"/>
                 </a:solidFill>
@@ -14595,7 +14595,7 @@
               </a:rPr>
               <a:t>01</a:t>
             </a:r>
-            <a:endParaRPr lang="en-US" sz="1050" dirty="0"/>
+            <a:endParaRPr lang="en-US" sz="1000" dirty="0"/>
           </a:p>
         </p:txBody>
       </p:sp>
@@ -14607,8 +14607,8 @@
         </p:nvSpPr>
         <p:spPr>
           <a:xfrm>
-            <a:off x="877824" y="1938528"/>
-            <a:ext cx="1531254" cy="420624"/>
+            <a:off x="859536" y="1847088"/>
+            <a:ext cx="1567830" cy="530352"/>
           </a:xfrm>
           <a:prstGeom prst="rect">
             <a:avLst/>
@@ -14622,12 +14622,12 @@
           <a:p>
             <a:pPr indent="0" marL="0">
               <a:lnSpc>
-                <a:spcPct val="105000"/>
+                <a:spcPct val="115000"/>
               </a:lnSpc>
               <a:buNone/>
             </a:pPr>
             <a:r>
-              <a:rPr lang="en-US" sz="1400" b="1" dirty="0">
+              <a:rPr lang="en-US" sz="1300" b="1" dirty="0">
                 <a:solidFill>
                   <a:srgbClr val="0F1B33"/>
                 </a:solidFill>
@@ -14635,9 +14635,9 @@
                 <a:ea typeface="Calibri" pitchFamily="34" charset="-122"/>
                 <a:cs typeface="Calibri" pitchFamily="34" charset="-120"/>
               </a:rPr>
-              <a:t>아이디어</a:t>
-            </a:r>
-            <a:endParaRPr lang="en-US" sz="1400" dirty="0"/>
+              <a:t>하고 싶은 것 말하기</a:t>
+            </a:r>
+            <a:endParaRPr lang="en-US" sz="1300" dirty="0"/>
           </a:p>
         </p:txBody>
       </p:sp>
@@ -14649,7 +14649,7 @@
         </p:nvSpPr>
         <p:spPr>
           <a:xfrm>
-            <a:off x="2646822" y="1828800"/>
+            <a:off x="2646822" y="1920240"/>
             <a:ext cx="219456" cy="329184"/>
           </a:xfrm>
           <a:prstGeom prst="rect">
@@ -14688,12 +14688,12 @@
         </p:nvSpPr>
         <p:spPr>
           <a:xfrm>
-            <a:off x="2866278" y="1517904"/>
-            <a:ext cx="2006742" cy="950976"/>
+            <a:off x="2866278" y="1481328"/>
+            <a:ext cx="2006742" cy="1207008"/>
           </a:xfrm>
           <a:prstGeom prst="roundRect">
             <a:avLst>
-              <a:gd name="adj" fmla="val 6731"/>
+              <a:gd name="adj" fmla="val 5303"/>
             </a:avLst>
           </a:prstGeom>
           <a:solidFill>
@@ -14710,24 +14710,24 @@
         </p:nvSpPr>
         <p:spPr>
           <a:xfrm>
-            <a:off x="3104022" y="1664208"/>
-            <a:ext cx="1531254" cy="219456"/>
-          </a:xfrm>
-          <a:prstGeom prst="rect">
-            <a:avLst/>
-          </a:prstGeom>
-          <a:noFill/>
-          <a:ln/>
-        </p:spPr>
-        <p:txBody>
-          <a:bodyPr wrap="square" lIns="0" tIns="0" rIns="0" bIns="0" rtlCol="0" anchor="ctr"/>
-          <a:lstStyle/>
-          <a:p>
-            <a:pPr indent="0" marL="0">
-              <a:buNone/>
-            </a:pPr>
-            <a:r>
-              <a:rPr lang="en-US" sz="1050" b="1" dirty="0">
+            <a:off x="3085734" y="1609344"/>
+            <a:ext cx="1567830" cy="201168"/>
+          </a:xfrm>
+          <a:prstGeom prst="rect">
+            <a:avLst/>
+          </a:prstGeom>
+          <a:noFill/>
+          <a:ln/>
+        </p:spPr>
+        <p:txBody>
+          <a:bodyPr wrap="square" lIns="0" tIns="0" rIns="0" bIns="0" rtlCol="0" anchor="ctr"/>
+          <a:lstStyle/>
+          <a:p>
+            <a:pPr indent="0" marL="0">
+              <a:buNone/>
+            </a:pPr>
+            <a:r>
+              <a:rPr lang="en-US" sz="1000" b="1" dirty="0">
                 <a:solidFill>
                   <a:srgbClr val="8A94A6"/>
                 </a:solidFill>
@@ -14737,7 +14737,7 @@
               </a:rPr>
               <a:t>02</a:t>
             </a:r>
-            <a:endParaRPr lang="en-US" sz="1050" dirty="0"/>
+            <a:endParaRPr lang="en-US" sz="1000" dirty="0"/>
           </a:p>
         </p:txBody>
       </p:sp>
@@ -14749,8 +14749,8 @@
         </p:nvSpPr>
         <p:spPr>
           <a:xfrm>
-            <a:off x="3104022" y="1938528"/>
-            <a:ext cx="1531254" cy="420624"/>
+            <a:off x="3085734" y="1847088"/>
+            <a:ext cx="1567830" cy="530352"/>
           </a:xfrm>
           <a:prstGeom prst="rect">
             <a:avLst/>
@@ -14764,12 +14764,12 @@
           <a:p>
             <a:pPr indent="0" marL="0">
               <a:lnSpc>
-                <a:spcPct val="105000"/>
+                <a:spcPct val="115000"/>
               </a:lnSpc>
               <a:buNone/>
             </a:pPr>
             <a:r>
-              <a:rPr lang="en-US" sz="1400" b="1" dirty="0">
+              <a:rPr lang="en-US" sz="1300" b="1" dirty="0">
                 <a:solidFill>
                   <a:srgbClr val="0F1B33"/>
                 </a:solidFill>
@@ -14777,21 +14777,60 @@
                 <a:ea typeface="Calibri" pitchFamily="34" charset="-122"/>
                 <a:cs typeface="Calibri" pitchFamily="34" charset="-120"/>
               </a:rPr>
+              <a:t>질문으로 조건 좁히기</a:t>
+            </a:r>
+            <a:endParaRPr lang="en-US" sz="1300" dirty="0"/>
+          </a:p>
+        </p:txBody>
+      </p:sp>
+      <p:sp>
+        <p:nvSpPr>
+          <p:cNvPr id="13" name="Text 11"/>
+          <p:cNvSpPr txBox="1"/>
+          <p:nvPr/>
+        </p:nvSpPr>
+        <p:spPr>
+          <a:xfrm>
+            <a:off x="3085734" y="2395728"/>
+            <a:ext cx="1567830" cy="219456"/>
+          </a:xfrm>
+          <a:prstGeom prst="rect">
+            <a:avLst/>
+          </a:prstGeom>
+          <a:noFill/>
+          <a:ln/>
+        </p:spPr>
+        <p:txBody>
+          <a:bodyPr wrap="square" lIns="0" tIns="0" rIns="0" bIns="0" rtlCol="0" anchor="ctr"/>
+          <a:lstStyle/>
+          <a:p>
+            <a:pPr indent="0" marL="0">
+              <a:buNone/>
+            </a:pPr>
+            <a:r>
+              <a:rPr lang="en-US" sz="950" dirty="0">
+                <a:solidFill>
+                  <a:srgbClr val="5B6577"/>
+                </a:solidFill>
+                <a:latin typeface="Calibri" pitchFamily="34" charset="0"/>
+                <a:ea typeface="Calibri" pitchFamily="34" charset="-122"/>
+                <a:cs typeface="Calibri" pitchFamily="34" charset="-120"/>
+              </a:rPr>
               <a:t>Brainstorming</a:t>
             </a:r>
-            <a:endParaRPr lang="en-US" sz="1400" dirty="0"/>
-          </a:p>
-        </p:txBody>
-      </p:sp>
-      <p:sp>
-        <p:nvSpPr>
-          <p:cNvPr id="13" name="Text 11"/>
-          <p:cNvSpPr txBox="1"/>
-          <p:nvPr/>
-        </p:nvSpPr>
-        <p:spPr>
-          <a:xfrm>
-            <a:off x="4873020" y="1828800"/>
+            <a:endParaRPr lang="en-US" sz="950" dirty="0"/>
+          </a:p>
+        </p:txBody>
+      </p:sp>
+      <p:sp>
+        <p:nvSpPr>
+          <p:cNvPr id="14" name="Text 12"/>
+          <p:cNvSpPr txBox="1"/>
+          <p:nvPr/>
+        </p:nvSpPr>
+        <p:spPr>
+          <a:xfrm>
+            <a:off x="4873020" y="1920240"/>
             <a:ext cx="219456" cy="329184"/>
           </a:xfrm>
           <a:prstGeom prst="rect">
@@ -14824,18 +14863,18 @@
       </p:sp>
       <p:sp>
         <p:nvSpPr>
-          <p:cNvPr id="14" name="Shape 12"/>
+          <p:cNvPr id="15" name="Shape 13"/>
           <p:cNvSpPr/>
           <p:nvPr/>
         </p:nvSpPr>
         <p:spPr>
           <a:xfrm>
-            <a:off x="5092476" y="1517904"/>
-            <a:ext cx="2006742" cy="950976"/>
+            <a:off x="5092476" y="1481328"/>
+            <a:ext cx="2006742" cy="1207008"/>
           </a:xfrm>
           <a:prstGeom prst="roundRect">
             <a:avLst>
-              <a:gd name="adj" fmla="val 6731"/>
+              <a:gd name="adj" fmla="val 5303"/>
             </a:avLst>
           </a:prstGeom>
           <a:solidFill>
@@ -14846,30 +14885,30 @@
       </p:sp>
       <p:sp>
         <p:nvSpPr>
-          <p:cNvPr id="15" name="Text 13"/>
-          <p:cNvSpPr txBox="1"/>
-          <p:nvPr/>
-        </p:nvSpPr>
-        <p:spPr>
-          <a:xfrm>
-            <a:off x="5330220" y="1664208"/>
-            <a:ext cx="1531254" cy="219456"/>
-          </a:xfrm>
-          <a:prstGeom prst="rect">
-            <a:avLst/>
-          </a:prstGeom>
-          <a:noFill/>
-          <a:ln/>
-        </p:spPr>
-        <p:txBody>
-          <a:bodyPr wrap="square" lIns="0" tIns="0" rIns="0" bIns="0" rtlCol="0" anchor="ctr"/>
-          <a:lstStyle/>
-          <a:p>
-            <a:pPr indent="0" marL="0">
-              <a:buNone/>
-            </a:pPr>
-            <a:r>
-              <a:rPr lang="en-US" sz="1050" b="1" dirty="0">
+          <p:cNvPr id="16" name="Text 14"/>
+          <p:cNvSpPr txBox="1"/>
+          <p:nvPr/>
+        </p:nvSpPr>
+        <p:spPr>
+          <a:xfrm>
+            <a:off x="5311932" y="1609344"/>
+            <a:ext cx="1567830" cy="201168"/>
+          </a:xfrm>
+          <a:prstGeom prst="rect">
+            <a:avLst/>
+          </a:prstGeom>
+          <a:noFill/>
+          <a:ln/>
+        </p:spPr>
+        <p:txBody>
+          <a:bodyPr wrap="square" lIns="0" tIns="0" rIns="0" bIns="0" rtlCol="0" anchor="ctr"/>
+          <a:lstStyle/>
+          <a:p>
+            <a:pPr indent="0" marL="0">
+              <a:buNone/>
+            </a:pPr>
+            <a:r>
+              <a:rPr lang="en-US" sz="1000" b="1" dirty="0">
                 <a:solidFill>
                   <a:srgbClr val="8A94A6"/>
                 </a:solidFill>
@@ -14879,20 +14918,20 @@
               </a:rPr>
               <a:t>03</a:t>
             </a:r>
-            <a:endParaRPr lang="en-US" sz="1050" dirty="0"/>
-          </a:p>
-        </p:txBody>
-      </p:sp>
-      <p:sp>
-        <p:nvSpPr>
-          <p:cNvPr id="16" name="Text 14"/>
-          <p:cNvSpPr txBox="1"/>
-          <p:nvPr/>
-        </p:nvSpPr>
-        <p:spPr>
-          <a:xfrm>
-            <a:off x="5330220" y="1938528"/>
-            <a:ext cx="1531254" cy="420624"/>
+            <a:endParaRPr lang="en-US" sz="1000" dirty="0"/>
+          </a:p>
+        </p:txBody>
+      </p:sp>
+      <p:sp>
+        <p:nvSpPr>
+          <p:cNvPr id="17" name="Text 15"/>
+          <p:cNvSpPr txBox="1"/>
+          <p:nvPr/>
+        </p:nvSpPr>
+        <p:spPr>
+          <a:xfrm>
+            <a:off x="5311932" y="1847088"/>
+            <a:ext cx="1567830" cy="530352"/>
           </a:xfrm>
           <a:prstGeom prst="rect">
             <a:avLst/>
@@ -14906,12 +14945,12 @@
           <a:p>
             <a:pPr indent="0" marL="0">
               <a:lnSpc>
-                <a:spcPct val="105000"/>
+                <a:spcPct val="115000"/>
               </a:lnSpc>
               <a:buNone/>
             </a:pPr>
             <a:r>
-              <a:rPr lang="en-US" sz="1400" b="1" dirty="0">
+              <a:rPr lang="en-US" sz="1300" b="1" dirty="0">
                 <a:solidFill>
                   <a:srgbClr val="0F1B33"/>
                 </a:solidFill>
@@ -14919,21 +14958,60 @@
                 <a:ea typeface="Calibri" pitchFamily="34" charset="-122"/>
                 <a:cs typeface="Calibri" pitchFamily="34" charset="-120"/>
               </a:rPr>
+              <a:t>할 일을 잘게 쪼개기</a:t>
+            </a:r>
+            <a:endParaRPr lang="en-US" sz="1300" dirty="0"/>
+          </a:p>
+        </p:txBody>
+      </p:sp>
+      <p:sp>
+        <p:nvSpPr>
+          <p:cNvPr id="18" name="Text 16"/>
+          <p:cNvSpPr txBox="1"/>
+          <p:nvPr/>
+        </p:nvSpPr>
+        <p:spPr>
+          <a:xfrm>
+            <a:off x="5311932" y="2395728"/>
+            <a:ext cx="1567830" cy="219456"/>
+          </a:xfrm>
+          <a:prstGeom prst="rect">
+            <a:avLst/>
+          </a:prstGeom>
+          <a:noFill/>
+          <a:ln/>
+        </p:spPr>
+        <p:txBody>
+          <a:bodyPr wrap="square" lIns="0" tIns="0" rIns="0" bIns="0" rtlCol="0" anchor="ctr"/>
+          <a:lstStyle/>
+          <a:p>
+            <a:pPr indent="0" marL="0">
+              <a:buNone/>
+            </a:pPr>
+            <a:r>
+              <a:rPr lang="en-US" sz="950" dirty="0">
+                <a:solidFill>
+                  <a:srgbClr val="5B6577"/>
+                </a:solidFill>
+                <a:latin typeface="Calibri" pitchFamily="34" charset="0"/>
+                <a:ea typeface="Calibri" pitchFamily="34" charset="-122"/>
+                <a:cs typeface="Calibri" pitchFamily="34" charset="-120"/>
+              </a:rPr>
               <a:t>Writing Plans</a:t>
             </a:r>
-            <a:endParaRPr lang="en-US" sz="1400" dirty="0"/>
-          </a:p>
-        </p:txBody>
-      </p:sp>
-      <p:sp>
-        <p:nvSpPr>
-          <p:cNvPr id="17" name="Text 15"/>
-          <p:cNvSpPr txBox="1"/>
-          <p:nvPr/>
-        </p:nvSpPr>
-        <p:spPr>
-          <a:xfrm>
-            <a:off x="7099219" y="1828800"/>
+            <a:endParaRPr lang="en-US" sz="950" dirty="0"/>
+          </a:p>
+        </p:txBody>
+      </p:sp>
+      <p:sp>
+        <p:nvSpPr>
+          <p:cNvPr id="19" name="Text 17"/>
+          <p:cNvSpPr txBox="1"/>
+          <p:nvPr/>
+        </p:nvSpPr>
+        <p:spPr>
+          <a:xfrm>
+            <a:off x="7099219" y="1920240"/>
             <a:ext cx="219456" cy="329184"/>
           </a:xfrm>
           <a:prstGeom prst="rect">
@@ -14966,18 +15044,18 @@
       </p:sp>
       <p:sp>
         <p:nvSpPr>
-          <p:cNvPr id="18" name="Shape 16"/>
+          <p:cNvPr id="20" name="Shape 18"/>
           <p:cNvSpPr/>
           <p:nvPr/>
         </p:nvSpPr>
         <p:spPr>
           <a:xfrm>
-            <a:off x="7318675" y="1517904"/>
-            <a:ext cx="2006742" cy="950976"/>
+            <a:off x="7318675" y="1481328"/>
+            <a:ext cx="2006742" cy="1207008"/>
           </a:xfrm>
           <a:prstGeom prst="roundRect">
             <a:avLst>
-              <a:gd name="adj" fmla="val 6731"/>
+              <a:gd name="adj" fmla="val 5303"/>
             </a:avLst>
           </a:prstGeom>
           <a:solidFill>
@@ -14988,30 +15066,30 @@
       </p:sp>
       <p:sp>
         <p:nvSpPr>
-          <p:cNvPr id="19" name="Text 17"/>
-          <p:cNvSpPr txBox="1"/>
-          <p:nvPr/>
-        </p:nvSpPr>
-        <p:spPr>
-          <a:xfrm>
-            <a:off x="7556419" y="1664208"/>
-            <a:ext cx="1531254" cy="219456"/>
-          </a:xfrm>
-          <a:prstGeom prst="rect">
-            <a:avLst/>
-          </a:prstGeom>
-          <a:noFill/>
-          <a:ln/>
-        </p:spPr>
-        <p:txBody>
-          <a:bodyPr wrap="square" lIns="0" tIns="0" rIns="0" bIns="0" rtlCol="0" anchor="ctr"/>
-          <a:lstStyle/>
-          <a:p>
-            <a:pPr indent="0" marL="0">
-              <a:buNone/>
-            </a:pPr>
-            <a:r>
-              <a:rPr lang="en-US" sz="1050" b="1" dirty="0">
+          <p:cNvPr id="21" name="Text 19"/>
+          <p:cNvSpPr txBox="1"/>
+          <p:nvPr/>
+        </p:nvSpPr>
+        <p:spPr>
+          <a:xfrm>
+            <a:off x="7538131" y="1609344"/>
+            <a:ext cx="1567830" cy="201168"/>
+          </a:xfrm>
+          <a:prstGeom prst="rect">
+            <a:avLst/>
+          </a:prstGeom>
+          <a:noFill/>
+          <a:ln/>
+        </p:spPr>
+        <p:txBody>
+          <a:bodyPr wrap="square" lIns="0" tIns="0" rIns="0" bIns="0" rtlCol="0" anchor="ctr"/>
+          <a:lstStyle/>
+          <a:p>
+            <a:pPr indent="0" marL="0">
+              <a:buNone/>
+            </a:pPr>
+            <a:r>
+              <a:rPr lang="en-US" sz="1000" b="1" dirty="0">
                 <a:solidFill>
                   <a:srgbClr val="9FB8FF"/>
                 </a:solidFill>
@@ -15021,20 +15099,20 @@
               </a:rPr>
               <a:t>04</a:t>
             </a:r>
-            <a:endParaRPr lang="en-US" sz="1050" dirty="0"/>
-          </a:p>
-        </p:txBody>
-      </p:sp>
-      <p:sp>
-        <p:nvSpPr>
-          <p:cNvPr id="20" name="Text 18"/>
-          <p:cNvSpPr txBox="1"/>
-          <p:nvPr/>
-        </p:nvSpPr>
-        <p:spPr>
-          <a:xfrm>
-            <a:off x="7556419" y="1938528"/>
-            <a:ext cx="1531254" cy="420624"/>
+            <a:endParaRPr lang="en-US" sz="1000" dirty="0"/>
+          </a:p>
+        </p:txBody>
+      </p:sp>
+      <p:sp>
+        <p:nvSpPr>
+          <p:cNvPr id="22" name="Text 20"/>
+          <p:cNvSpPr txBox="1"/>
+          <p:nvPr/>
+        </p:nvSpPr>
+        <p:spPr>
+          <a:xfrm>
+            <a:off x="7538131" y="1847088"/>
+            <a:ext cx="1567830" cy="530352"/>
           </a:xfrm>
           <a:prstGeom prst="rect">
             <a:avLst/>
@@ -15048,12 +15126,12 @@
           <a:p>
             <a:pPr indent="0" marL="0">
               <a:lnSpc>
-                <a:spcPct val="105000"/>
+                <a:spcPct val="115000"/>
               </a:lnSpc>
               <a:buNone/>
             </a:pPr>
             <a:r>
-              <a:rPr lang="en-US" sz="1400" b="1" dirty="0">
+              <a:rPr lang="en-US" sz="1300" b="1" dirty="0">
                 <a:solidFill>
                   <a:srgbClr val="FFFFFF"/>
                 </a:solidFill>
@@ -15061,21 +15139,60 @@
                 <a:ea typeface="Calibri" pitchFamily="34" charset="-122"/>
                 <a:cs typeface="Calibri" pitchFamily="34" charset="-120"/>
               </a:rPr>
-              <a:t>TDD 구현</a:t>
-            </a:r>
-            <a:endParaRPr lang="en-US" sz="1400" dirty="0"/>
-          </a:p>
-        </p:txBody>
-      </p:sp>
-      <p:sp>
-        <p:nvSpPr>
-          <p:cNvPr id="21" name="Text 19"/>
-          <p:cNvSpPr txBox="1"/>
-          <p:nvPr/>
-        </p:nvSpPr>
-        <p:spPr>
-          <a:xfrm>
-            <a:off x="9325417" y="1828800"/>
+              <a:t>테스트 먼저, 구현 나중</a:t>
+            </a:r>
+            <a:endParaRPr lang="en-US" sz="1300" dirty="0"/>
+          </a:p>
+        </p:txBody>
+      </p:sp>
+      <p:sp>
+        <p:nvSpPr>
+          <p:cNvPr id="23" name="Text 21"/>
+          <p:cNvSpPr txBox="1"/>
+          <p:nvPr/>
+        </p:nvSpPr>
+        <p:spPr>
+          <a:xfrm>
+            <a:off x="7538131" y="2395728"/>
+            <a:ext cx="1567830" cy="219456"/>
+          </a:xfrm>
+          <a:prstGeom prst="rect">
+            <a:avLst/>
+          </a:prstGeom>
+          <a:noFill/>
+          <a:ln/>
+        </p:spPr>
+        <p:txBody>
+          <a:bodyPr wrap="square" lIns="0" tIns="0" rIns="0" bIns="0" rtlCol="0" anchor="ctr"/>
+          <a:lstStyle/>
+          <a:p>
+            <a:pPr indent="0" marL="0">
+              <a:buNone/>
+            </a:pPr>
+            <a:r>
+              <a:rPr lang="en-US" sz="950" dirty="0">
+                <a:solidFill>
+                  <a:srgbClr val="DCE7FF"/>
+                </a:solidFill>
+                <a:latin typeface="Calibri" pitchFamily="34" charset="0"/>
+                <a:ea typeface="Calibri" pitchFamily="34" charset="-122"/>
+                <a:cs typeface="Calibri" pitchFamily="34" charset="-120"/>
+              </a:rPr>
+              <a:t>TDD</a:t>
+            </a:r>
+            <a:endParaRPr lang="en-US" sz="950" dirty="0"/>
+          </a:p>
+        </p:txBody>
+      </p:sp>
+      <p:sp>
+        <p:nvSpPr>
+          <p:cNvPr id="24" name="Text 22"/>
+          <p:cNvSpPr txBox="1"/>
+          <p:nvPr/>
+        </p:nvSpPr>
+        <p:spPr>
+          <a:xfrm>
+            <a:off x="9325417" y="1920240"/>
             <a:ext cx="219456" cy="329184"/>
           </a:xfrm>
           <a:prstGeom prst="rect">
@@ -15108,18 +15225,18 @@
       </p:sp>
       <p:sp>
         <p:nvSpPr>
-          <p:cNvPr id="22" name="Shape 20"/>
+          <p:cNvPr id="25" name="Shape 23"/>
           <p:cNvSpPr/>
           <p:nvPr/>
         </p:nvSpPr>
         <p:spPr>
           <a:xfrm>
-            <a:off x="9544873" y="1517904"/>
-            <a:ext cx="2006742" cy="950976"/>
+            <a:off x="9544873" y="1481328"/>
+            <a:ext cx="2006742" cy="1207008"/>
           </a:xfrm>
           <a:prstGeom prst="roundRect">
             <a:avLst>
-              <a:gd name="adj" fmla="val 6731"/>
+              <a:gd name="adj" fmla="val 5303"/>
             </a:avLst>
           </a:prstGeom>
           <a:solidFill>
@@ -15130,30 +15247,30 @@
       </p:sp>
       <p:sp>
         <p:nvSpPr>
-          <p:cNvPr id="23" name="Text 21"/>
-          <p:cNvSpPr txBox="1"/>
-          <p:nvPr/>
-        </p:nvSpPr>
-        <p:spPr>
-          <a:xfrm>
-            <a:off x="9782617" y="1664208"/>
-            <a:ext cx="1531254" cy="219456"/>
-          </a:xfrm>
-          <a:prstGeom prst="rect">
-            <a:avLst/>
-          </a:prstGeom>
-          <a:noFill/>
-          <a:ln/>
-        </p:spPr>
-        <p:txBody>
-          <a:bodyPr wrap="square" lIns="0" tIns="0" rIns="0" bIns="0" rtlCol="0" anchor="ctr"/>
-          <a:lstStyle/>
-          <a:p>
-            <a:pPr indent="0" marL="0">
-              <a:buNone/>
-            </a:pPr>
-            <a:r>
-              <a:rPr lang="en-US" sz="1050" b="1" dirty="0">
+          <p:cNvPr id="26" name="Text 24"/>
+          <p:cNvSpPr txBox="1"/>
+          <p:nvPr/>
+        </p:nvSpPr>
+        <p:spPr>
+          <a:xfrm>
+            <a:off x="9764329" y="1609344"/>
+            <a:ext cx="1567830" cy="201168"/>
+          </a:xfrm>
+          <a:prstGeom prst="rect">
+            <a:avLst/>
+          </a:prstGeom>
+          <a:noFill/>
+          <a:ln/>
+        </p:spPr>
+        <p:txBody>
+          <a:bodyPr wrap="square" lIns="0" tIns="0" rIns="0" bIns="0" rtlCol="0" anchor="ctr"/>
+          <a:lstStyle/>
+          <a:p>
+            <a:pPr indent="0" marL="0">
+              <a:buNone/>
+            </a:pPr>
+            <a:r>
+              <a:rPr lang="en-US" sz="1000" b="1" dirty="0">
                 <a:solidFill>
                   <a:srgbClr val="9FB8FF"/>
                 </a:solidFill>
@@ -15163,101 +15280,140 @@
               </a:rPr>
               <a:t>05</a:t>
             </a:r>
+            <a:endParaRPr lang="en-US" sz="1000" dirty="0"/>
+          </a:p>
+        </p:txBody>
+      </p:sp>
+      <p:sp>
+        <p:nvSpPr>
+          <p:cNvPr id="27" name="Text 25"/>
+          <p:cNvSpPr txBox="1"/>
+          <p:nvPr/>
+        </p:nvSpPr>
+        <p:spPr>
+          <a:xfrm>
+            <a:off x="9764329" y="1847088"/>
+            <a:ext cx="1567830" cy="530352"/>
+          </a:xfrm>
+          <a:prstGeom prst="rect">
+            <a:avLst/>
+          </a:prstGeom>
+          <a:noFill/>
+          <a:ln/>
+        </p:spPr>
+        <p:txBody>
+          <a:bodyPr wrap="square" lIns="0" tIns="0" rIns="0" bIns="0" rtlCol="0" anchor="ctr"/>
+          <a:lstStyle/>
+          <a:p>
+            <a:pPr indent="0" marL="0">
+              <a:lnSpc>
+                <a:spcPct val="115000"/>
+              </a:lnSpc>
+              <a:buNone/>
+            </a:pPr>
+            <a:r>
+              <a:rPr lang="en-US" sz="1300" b="1" dirty="0">
+                <a:solidFill>
+                  <a:srgbClr val="FFFFFF"/>
+                </a:solidFill>
+                <a:latin typeface="Calibri" pitchFamily="34" charset="0"/>
+                <a:ea typeface="Calibri" pitchFamily="34" charset="-122"/>
+                <a:cs typeface="Calibri" pitchFamily="34" charset="-120"/>
+              </a:rPr>
+              <a:t>증거로 확인하고 끝내기</a:t>
+            </a:r>
+            <a:endParaRPr lang="en-US" sz="1300" dirty="0"/>
+          </a:p>
+        </p:txBody>
+      </p:sp>
+      <p:sp>
+        <p:nvSpPr>
+          <p:cNvPr id="28" name="Text 26"/>
+          <p:cNvSpPr txBox="1"/>
+          <p:nvPr/>
+        </p:nvSpPr>
+        <p:spPr>
+          <a:xfrm>
+            <a:off x="9764329" y="2395728"/>
+            <a:ext cx="1567830" cy="219456"/>
+          </a:xfrm>
+          <a:prstGeom prst="rect">
+            <a:avLst/>
+          </a:prstGeom>
+          <a:noFill/>
+          <a:ln/>
+        </p:spPr>
+        <p:txBody>
+          <a:bodyPr wrap="square" lIns="0" tIns="0" rIns="0" bIns="0" rtlCol="0" anchor="ctr"/>
+          <a:lstStyle/>
+          <a:p>
+            <a:pPr indent="0" marL="0">
+              <a:buNone/>
+            </a:pPr>
+            <a:r>
+              <a:rPr lang="en-US" sz="950" dirty="0">
+                <a:solidFill>
+                  <a:srgbClr val="8FA2BC"/>
+                </a:solidFill>
+                <a:latin typeface="Calibri" pitchFamily="34" charset="0"/>
+                <a:ea typeface="Calibri" pitchFamily="34" charset="-122"/>
+                <a:cs typeface="Calibri" pitchFamily="34" charset="-120"/>
+              </a:rPr>
+              <a:t>검증 · 완료</a:t>
+            </a:r>
+            <a:endParaRPr lang="en-US" sz="950" dirty="0"/>
+          </a:p>
+        </p:txBody>
+      </p:sp>
+      <p:sp>
+        <p:nvSpPr>
+          <p:cNvPr id="29" name="Text 27"/>
+          <p:cNvSpPr txBox="1"/>
+          <p:nvPr/>
+        </p:nvSpPr>
+        <p:spPr>
+          <a:xfrm>
+            <a:off x="640080" y="2926080"/>
+            <a:ext cx="5486400" cy="237744"/>
+          </a:xfrm>
+          <a:prstGeom prst="rect">
+            <a:avLst/>
+          </a:prstGeom>
+          <a:noFill/>
+          <a:ln/>
+        </p:spPr>
+        <p:txBody>
+          <a:bodyPr wrap="square" lIns="0" tIns="0" rIns="0" bIns="0" rtlCol="0" anchor="ctr"/>
+          <a:lstStyle/>
+          <a:p>
+            <a:pPr indent="0" marL="0">
+              <a:buNone/>
+            </a:pPr>
+            <a:r>
+              <a:rPr lang="en-US" sz="1050" b="1" spc="60" kern="0" dirty="0">
+                <a:solidFill>
+                  <a:srgbClr val="2F6BFF"/>
+                </a:solidFill>
+                <a:latin typeface="Calibri" pitchFamily="34" charset="0"/>
+                <a:ea typeface="Calibri" pitchFamily="34" charset="-122"/>
+                <a:cs typeface="Calibri" pitchFamily="34" charset="-120"/>
+              </a:rPr>
+              <a:t>그래서 무엇이 나오는가</a:t>
+            </a:r>
             <a:endParaRPr lang="en-US" sz="1050" dirty="0"/>
           </a:p>
         </p:txBody>
       </p:sp>
       <p:sp>
         <p:nvSpPr>
-          <p:cNvPr id="24" name="Text 22"/>
-          <p:cNvSpPr txBox="1"/>
-          <p:nvPr/>
-        </p:nvSpPr>
-        <p:spPr>
-          <a:xfrm>
-            <a:off x="9782617" y="1938528"/>
-            <a:ext cx="1531254" cy="420624"/>
-          </a:xfrm>
-          <a:prstGeom prst="rect">
-            <a:avLst/>
-          </a:prstGeom>
-          <a:noFill/>
-          <a:ln/>
-        </p:spPr>
-        <p:txBody>
-          <a:bodyPr wrap="square" lIns="0" tIns="0" rIns="0" bIns="0" rtlCol="0" anchor="ctr"/>
-          <a:lstStyle/>
-          <a:p>
-            <a:pPr indent="0" marL="0">
-              <a:lnSpc>
-                <a:spcPct val="105000"/>
-              </a:lnSpc>
-              <a:buNone/>
-            </a:pPr>
-            <a:r>
-              <a:rPr lang="en-US" sz="1400" b="1" dirty="0">
-                <a:solidFill>
-                  <a:srgbClr val="FFFFFF"/>
-                </a:solidFill>
-                <a:latin typeface="Calibri" pitchFamily="34" charset="0"/>
-                <a:ea typeface="Calibri" pitchFamily="34" charset="-122"/>
-                <a:cs typeface="Calibri" pitchFamily="34" charset="-120"/>
-              </a:rPr>
-              <a:t>검증 · 완료</a:t>
-            </a:r>
-            <a:endParaRPr lang="en-US" sz="1400" dirty="0"/>
-          </a:p>
-        </p:txBody>
-      </p:sp>
-      <p:sp>
-        <p:nvSpPr>
-          <p:cNvPr id="25" name="Text 23"/>
-          <p:cNvSpPr txBox="1"/>
-          <p:nvPr/>
-        </p:nvSpPr>
-        <p:spPr>
-          <a:xfrm>
-            <a:off x="640080" y="2761488"/>
-            <a:ext cx="5486400" cy="237744"/>
-          </a:xfrm>
-          <a:prstGeom prst="rect">
-            <a:avLst/>
-          </a:prstGeom>
-          <a:noFill/>
-          <a:ln/>
-        </p:spPr>
-        <p:txBody>
-          <a:bodyPr wrap="square" lIns="0" tIns="0" rIns="0" bIns="0" rtlCol="0" anchor="ctr"/>
-          <a:lstStyle/>
-          <a:p>
-            <a:pPr indent="0" marL="0">
-              <a:buNone/>
-            </a:pPr>
-            <a:r>
-              <a:rPr lang="en-US" sz="1050" b="1" spc="60" kern="0" dirty="0">
-                <a:solidFill>
-                  <a:srgbClr val="2F6BFF"/>
-                </a:solidFill>
-                <a:latin typeface="Calibri" pitchFamily="34" charset="0"/>
-                <a:ea typeface="Calibri" pitchFamily="34" charset="-122"/>
-                <a:cs typeface="Calibri" pitchFamily="34" charset="-120"/>
-              </a:rPr>
-              <a:t>그래서 무엇이 나오는가</a:t>
-            </a:r>
-            <a:endParaRPr lang="en-US" sz="1050" dirty="0"/>
-          </a:p>
-        </p:txBody>
-      </p:sp>
-      <p:sp>
-        <p:nvSpPr>
-          <p:cNvPr id="26" name="Text 24"/>
-          <p:cNvSpPr txBox="1"/>
-          <p:nvPr/>
-        </p:nvSpPr>
-        <p:spPr>
-          <a:xfrm>
-            <a:off x="640080" y="2487168"/>
-            <a:ext cx="2006742" cy="237744"/>
+          <p:cNvPr id="30" name="Text 28"/>
+          <p:cNvSpPr txBox="1"/>
+          <p:nvPr/>
+        </p:nvSpPr>
+        <p:spPr>
+          <a:xfrm>
+            <a:off x="640080" y="2706624"/>
+            <a:ext cx="2006742" cy="219456"/>
           </a:xfrm>
           <a:prstGeom prst="rect">
             <a:avLst/>
@@ -15289,18 +15445,18 @@
       </p:sp>
       <p:sp>
         <p:nvSpPr>
-          <p:cNvPr id="27" name="Shape 25"/>
+          <p:cNvPr id="31" name="Shape 29"/>
           <p:cNvSpPr/>
           <p:nvPr/>
         </p:nvSpPr>
         <p:spPr>
           <a:xfrm>
-            <a:off x="640080" y="3072384"/>
-            <a:ext cx="2006742" cy="1316736"/>
+            <a:off x="640080" y="3236976"/>
+            <a:ext cx="2006742" cy="1188720"/>
           </a:xfrm>
           <a:prstGeom prst="roundRect">
             <a:avLst>
-              <a:gd name="adj" fmla="val 4861"/>
+              <a:gd name="adj" fmla="val 5385"/>
             </a:avLst>
           </a:prstGeom>
           <a:solidFill>
@@ -15316,14 +15472,14 @@
       </p:sp>
       <p:sp>
         <p:nvSpPr>
-          <p:cNvPr id="28" name="Text 26"/>
-          <p:cNvSpPr txBox="1"/>
-          <p:nvPr/>
-        </p:nvSpPr>
-        <p:spPr>
-          <a:xfrm>
-            <a:off x="877824" y="3291840"/>
-            <a:ext cx="1531254" cy="877824"/>
+          <p:cNvPr id="32" name="Text 30"/>
+          <p:cNvSpPr txBox="1"/>
+          <p:nvPr/>
+        </p:nvSpPr>
+        <p:spPr>
+          <a:xfrm>
+            <a:off x="859536" y="3419856"/>
+            <a:ext cx="1567830" cy="822960"/>
           </a:xfrm>
           <a:prstGeom prst="rect">
             <a:avLst/>
@@ -15350,22 +15506,42 @@
                 <a:ea typeface="Calibri" pitchFamily="34" charset="-122"/>
                 <a:cs typeface="Calibri" pitchFamily="34" charset="-120"/>
               </a:rPr>
-              <a:t>만들고 싶은 것 한 문장</a:t>
+              <a:t>만들고 싶은 것</a:t>
             </a:r>
             <a:endParaRPr lang="en-US" sz="1150" dirty="0"/>
           </a:p>
-        </p:txBody>
-      </p:sp>
-      <p:sp>
-        <p:nvSpPr>
-          <p:cNvPr id="29" name="Text 27"/>
-          <p:cNvSpPr txBox="1"/>
-          <p:nvPr/>
-        </p:nvSpPr>
-        <p:spPr>
-          <a:xfrm>
-            <a:off x="2866278" y="2487168"/>
-            <a:ext cx="2006742" cy="237744"/>
+          <a:p>
+            <a:pPr indent="0" marL="0">
+              <a:lnSpc>
+                <a:spcPct val="130000"/>
+              </a:lnSpc>
+              <a:buNone/>
+            </a:pPr>
+            <a:r>
+              <a:rPr lang="en-US" sz="1150" dirty="0">
+                <a:solidFill>
+                  <a:srgbClr val="27374F"/>
+                </a:solidFill>
+                <a:latin typeface="Calibri" pitchFamily="34" charset="0"/>
+                <a:ea typeface="Calibri" pitchFamily="34" charset="-122"/>
+                <a:cs typeface="Calibri" pitchFamily="34" charset="-120"/>
+              </a:rPr>
+              <a:t>한 문장</a:t>
+            </a:r>
+            <a:endParaRPr lang="en-US" sz="1150" dirty="0"/>
+          </a:p>
+        </p:txBody>
+      </p:sp>
+      <p:sp>
+        <p:nvSpPr>
+          <p:cNvPr id="33" name="Text 31"/>
+          <p:cNvSpPr txBox="1"/>
+          <p:nvPr/>
+        </p:nvSpPr>
+        <p:spPr>
+          <a:xfrm>
+            <a:off x="2866278" y="2706624"/>
+            <a:ext cx="2006742" cy="219456"/>
           </a:xfrm>
           <a:prstGeom prst="rect">
             <a:avLst/>
@@ -15397,18 +15573,18 @@
       </p:sp>
       <p:sp>
         <p:nvSpPr>
-          <p:cNvPr id="30" name="Shape 28"/>
+          <p:cNvPr id="34" name="Shape 32"/>
           <p:cNvSpPr/>
           <p:nvPr/>
         </p:nvSpPr>
         <p:spPr>
           <a:xfrm>
-            <a:off x="2866278" y="3072384"/>
-            <a:ext cx="2006742" cy="1316736"/>
+            <a:off x="2866278" y="3236976"/>
+            <a:ext cx="2006742" cy="1188720"/>
           </a:xfrm>
           <a:prstGeom prst="roundRect">
             <a:avLst>
-              <a:gd name="adj" fmla="val 4861"/>
+              <a:gd name="adj" fmla="val 5385"/>
             </a:avLst>
           </a:prstGeom>
           <a:solidFill>
@@ -15424,14 +15600,14 @@
       </p:sp>
       <p:sp>
         <p:nvSpPr>
-          <p:cNvPr id="31" name="Text 29"/>
-          <p:cNvSpPr txBox="1"/>
-          <p:nvPr/>
-        </p:nvSpPr>
-        <p:spPr>
-          <a:xfrm>
-            <a:off x="3104022" y="3291840"/>
-            <a:ext cx="1531254" cy="877824"/>
+          <p:cNvPr id="35" name="Text 33"/>
+          <p:cNvSpPr txBox="1"/>
+          <p:nvPr/>
+        </p:nvSpPr>
+        <p:spPr>
+          <a:xfrm>
+            <a:off x="3085734" y="3419856"/>
+            <a:ext cx="1567830" cy="822960"/>
           </a:xfrm>
           <a:prstGeom prst="rect">
             <a:avLst/>
@@ -15458,22 +15634,42 @@
                 <a:ea typeface="Calibri" pitchFamily="34" charset="-122"/>
                 <a:cs typeface="Calibri" pitchFamily="34" charset="-120"/>
               </a:rPr>
-              <a:t>확정된 요구사항과 설계</a:t>
+              <a:t>확정된 요구사항과</a:t>
             </a:r>
             <a:endParaRPr lang="en-US" sz="1150" dirty="0"/>
           </a:p>
-        </p:txBody>
-      </p:sp>
-      <p:sp>
-        <p:nvSpPr>
-          <p:cNvPr id="32" name="Text 30"/>
-          <p:cNvSpPr txBox="1"/>
-          <p:nvPr/>
-        </p:nvSpPr>
-        <p:spPr>
-          <a:xfrm>
-            <a:off x="5092476" y="2487168"/>
-            <a:ext cx="2006742" cy="237744"/>
+          <a:p>
+            <a:pPr indent="0" marL="0">
+              <a:lnSpc>
+                <a:spcPct val="130000"/>
+              </a:lnSpc>
+              <a:buNone/>
+            </a:pPr>
+            <a:r>
+              <a:rPr lang="en-US" sz="1150" dirty="0">
+                <a:solidFill>
+                  <a:srgbClr val="27374F"/>
+                </a:solidFill>
+                <a:latin typeface="Calibri" pitchFamily="34" charset="0"/>
+                <a:ea typeface="Calibri" pitchFamily="34" charset="-122"/>
+                <a:cs typeface="Calibri" pitchFamily="34" charset="-120"/>
+              </a:rPr>
+              <a:t>설계</a:t>
+            </a:r>
+            <a:endParaRPr lang="en-US" sz="1150" dirty="0"/>
+          </a:p>
+        </p:txBody>
+      </p:sp>
+      <p:sp>
+        <p:nvSpPr>
+          <p:cNvPr id="36" name="Text 34"/>
+          <p:cNvSpPr txBox="1"/>
+          <p:nvPr/>
+        </p:nvSpPr>
+        <p:spPr>
+          <a:xfrm>
+            <a:off x="5092476" y="2706624"/>
+            <a:ext cx="2006742" cy="219456"/>
           </a:xfrm>
           <a:prstGeom prst="rect">
             <a:avLst/>
@@ -15505,18 +15701,18 @@
       </p:sp>
       <p:sp>
         <p:nvSpPr>
-          <p:cNvPr id="33" name="Shape 31"/>
+          <p:cNvPr id="37" name="Shape 35"/>
           <p:cNvSpPr/>
           <p:nvPr/>
         </p:nvSpPr>
         <p:spPr>
           <a:xfrm>
-            <a:off x="5092476" y="3072384"/>
-            <a:ext cx="2006742" cy="1316736"/>
+            <a:off x="5092476" y="3236976"/>
+            <a:ext cx="2006742" cy="1188720"/>
           </a:xfrm>
           <a:prstGeom prst="roundRect">
             <a:avLst>
-              <a:gd name="adj" fmla="val 4861"/>
+              <a:gd name="adj" fmla="val 5385"/>
             </a:avLst>
           </a:prstGeom>
           <a:solidFill>
@@ -15532,14 +15728,14 @@
       </p:sp>
       <p:sp>
         <p:nvSpPr>
-          <p:cNvPr id="34" name="Text 32"/>
-          <p:cNvSpPr txBox="1"/>
-          <p:nvPr/>
-        </p:nvSpPr>
-        <p:spPr>
-          <a:xfrm>
-            <a:off x="5330220" y="3291840"/>
-            <a:ext cx="1531254" cy="877824"/>
+          <p:cNvPr id="38" name="Text 36"/>
+          <p:cNvSpPr txBox="1"/>
+          <p:nvPr/>
+        </p:nvSpPr>
+        <p:spPr>
+          <a:xfrm>
+            <a:off x="5311932" y="3419856"/>
+            <a:ext cx="1567830" cy="822960"/>
           </a:xfrm>
           <a:prstGeom prst="rect">
             <a:avLst/>
@@ -15594,14 +15790,14 @@
       </p:sp>
       <p:sp>
         <p:nvSpPr>
-          <p:cNvPr id="35" name="Text 33"/>
-          <p:cNvSpPr txBox="1"/>
-          <p:nvPr/>
-        </p:nvSpPr>
-        <p:spPr>
-          <a:xfrm>
-            <a:off x="7318675" y="2487168"/>
-            <a:ext cx="2006742" cy="237744"/>
+          <p:cNvPr id="39" name="Text 37"/>
+          <p:cNvSpPr txBox="1"/>
+          <p:nvPr/>
+        </p:nvSpPr>
+        <p:spPr>
+          <a:xfrm>
+            <a:off x="7318675" y="2706624"/>
+            <a:ext cx="2006742" cy="219456"/>
           </a:xfrm>
           <a:prstGeom prst="rect">
             <a:avLst/>
@@ -15633,18 +15829,18 @@
       </p:sp>
       <p:sp>
         <p:nvSpPr>
-          <p:cNvPr id="36" name="Shape 34"/>
+          <p:cNvPr id="40" name="Shape 38"/>
           <p:cNvSpPr/>
           <p:nvPr/>
         </p:nvSpPr>
         <p:spPr>
           <a:xfrm>
-            <a:off x="7318675" y="3072384"/>
-            <a:ext cx="2006742" cy="1316736"/>
+            <a:off x="7318675" y="3236976"/>
+            <a:ext cx="2006742" cy="1188720"/>
           </a:xfrm>
           <a:prstGeom prst="roundRect">
             <a:avLst>
-              <a:gd name="adj" fmla="val 4861"/>
+              <a:gd name="adj" fmla="val 5385"/>
             </a:avLst>
           </a:prstGeom>
           <a:solidFill>
@@ -15660,14 +15856,14 @@
       </p:sp>
       <p:sp>
         <p:nvSpPr>
-          <p:cNvPr id="37" name="Text 35"/>
-          <p:cNvSpPr txBox="1"/>
-          <p:nvPr/>
-        </p:nvSpPr>
-        <p:spPr>
-          <a:xfrm>
-            <a:off x="7556419" y="3291840"/>
-            <a:ext cx="1531254" cy="877824"/>
+          <p:cNvPr id="41" name="Text 39"/>
+          <p:cNvSpPr txBox="1"/>
+          <p:nvPr/>
+        </p:nvSpPr>
+        <p:spPr>
+          <a:xfrm>
+            <a:off x="7538131" y="3419856"/>
+            <a:ext cx="1567830" cy="822960"/>
           </a:xfrm>
           <a:prstGeom prst="rect">
             <a:avLst/>
@@ -15694,22 +15890,42 @@
                 <a:ea typeface="Calibri" pitchFamily="34" charset="-122"/>
                 <a:cs typeface="Calibri" pitchFamily="34" charset="-120"/>
               </a:rPr>
-              <a:t>테스트를 통과한 코드</a:t>
+              <a:t>테스트를 통과한</a:t>
             </a:r>
             <a:endParaRPr lang="en-US" sz="1150" dirty="0"/>
           </a:p>
-        </p:txBody>
-      </p:sp>
-      <p:sp>
-        <p:nvSpPr>
-          <p:cNvPr id="38" name="Text 36"/>
-          <p:cNvSpPr txBox="1"/>
-          <p:nvPr/>
-        </p:nvSpPr>
-        <p:spPr>
-          <a:xfrm>
-            <a:off x="9544873" y="2487168"/>
-            <a:ext cx="2006742" cy="237744"/>
+          <a:p>
+            <a:pPr indent="0" marL="0">
+              <a:lnSpc>
+                <a:spcPct val="130000"/>
+              </a:lnSpc>
+              <a:buNone/>
+            </a:pPr>
+            <a:r>
+              <a:rPr lang="en-US" sz="1150" dirty="0">
+                <a:solidFill>
+                  <a:srgbClr val="27374F"/>
+                </a:solidFill>
+                <a:latin typeface="Calibri" pitchFamily="34" charset="0"/>
+                <a:ea typeface="Calibri" pitchFamily="34" charset="-122"/>
+                <a:cs typeface="Calibri" pitchFamily="34" charset="-120"/>
+              </a:rPr>
+              <a:t>코드</a:t>
+            </a:r>
+            <a:endParaRPr lang="en-US" sz="1150" dirty="0"/>
+          </a:p>
+        </p:txBody>
+      </p:sp>
+      <p:sp>
+        <p:nvSpPr>
+          <p:cNvPr id="42" name="Text 40"/>
+          <p:cNvSpPr txBox="1"/>
+          <p:nvPr/>
+        </p:nvSpPr>
+        <p:spPr>
+          <a:xfrm>
+            <a:off x="9544873" y="2706624"/>
+            <a:ext cx="2006742" cy="219456"/>
           </a:xfrm>
           <a:prstGeom prst="rect">
             <a:avLst/>
@@ -15741,18 +15957,18 @@
       </p:sp>
       <p:sp>
         <p:nvSpPr>
-          <p:cNvPr id="39" name="Shape 37"/>
+          <p:cNvPr id="43" name="Shape 41"/>
           <p:cNvSpPr/>
           <p:nvPr/>
         </p:nvSpPr>
         <p:spPr>
           <a:xfrm>
-            <a:off x="9544873" y="3072384"/>
-            <a:ext cx="2006742" cy="1316736"/>
+            <a:off x="9544873" y="3236976"/>
+            <a:ext cx="2006742" cy="1188720"/>
           </a:xfrm>
           <a:prstGeom prst="roundRect">
             <a:avLst>
-              <a:gd name="adj" fmla="val 4861"/>
+              <a:gd name="adj" fmla="val 5385"/>
             </a:avLst>
           </a:prstGeom>
           <a:solidFill>
@@ -15768,14 +15984,14 @@
       </p:sp>
       <p:sp>
         <p:nvSpPr>
-          <p:cNvPr id="40" name="Text 38"/>
-          <p:cNvSpPr txBox="1"/>
-          <p:nvPr/>
-        </p:nvSpPr>
-        <p:spPr>
-          <a:xfrm>
-            <a:off x="9782617" y="3291840"/>
-            <a:ext cx="1531254" cy="877824"/>
+          <p:cNvPr id="44" name="Text 42"/>
+          <p:cNvSpPr txBox="1"/>
+          <p:nvPr/>
+        </p:nvSpPr>
+        <p:spPr>
+          <a:xfrm>
+            <a:off x="9764329" y="3419856"/>
+            <a:ext cx="1567830" cy="822960"/>
           </a:xfrm>
           <a:prstGeom prst="rect">
             <a:avLst/>
@@ -15830,18 +16046,18 @@
       </p:sp>
       <p:sp>
         <p:nvSpPr>
-          <p:cNvPr id="41" name="Shape 39"/>
+          <p:cNvPr id="45" name="Shape 43"/>
           <p:cNvSpPr/>
           <p:nvPr/>
         </p:nvSpPr>
         <p:spPr>
           <a:xfrm>
-            <a:off x="640080" y="4700016"/>
-            <a:ext cx="10911535" cy="969264"/>
+            <a:off x="640080" y="4736592"/>
+            <a:ext cx="10911535" cy="914400"/>
           </a:xfrm>
           <a:prstGeom prst="roundRect">
             <a:avLst>
-              <a:gd name="adj" fmla="val 5660"/>
+              <a:gd name="adj" fmla="val 6000"/>
             </a:avLst>
           </a:prstGeom>
           <a:solidFill>
@@ -15852,13 +16068,13 @@
       </p:sp>
       <p:sp>
         <p:nvSpPr>
-          <p:cNvPr id="42" name="Shape 40"/>
+          <p:cNvPr id="46" name="Shape 44"/>
           <p:cNvSpPr/>
           <p:nvPr/>
         </p:nvSpPr>
         <p:spPr>
           <a:xfrm>
-            <a:off x="950976" y="5010912"/>
+            <a:off x="950976" y="5020056"/>
             <a:ext cx="1133856" cy="347472"/>
           </a:xfrm>
           <a:prstGeom prst="roundRect">
@@ -15874,13 +16090,13 @@
       </p:sp>
       <p:sp>
         <p:nvSpPr>
-          <p:cNvPr id="43" name="Text 41"/>
-          <p:cNvSpPr txBox="1"/>
-          <p:nvPr/>
-        </p:nvSpPr>
-        <p:spPr>
-          <a:xfrm>
-            <a:off x="950976" y="5010912"/>
+          <p:cNvPr id="47" name="Text 45"/>
+          <p:cNvSpPr txBox="1"/>
+          <p:nvPr/>
+        </p:nvSpPr>
+        <p:spPr>
+          <a:xfrm>
+            <a:off x="950976" y="5020056"/>
             <a:ext cx="1133856" cy="347472"/>
           </a:xfrm>
           <a:prstGeom prst="rect">
@@ -15913,25 +16129,39 @@
       </p:sp>
       <p:sp>
         <p:nvSpPr>
-          <p:cNvPr id="44" name="Text 42"/>
-          <p:cNvSpPr txBox="1"/>
-          <p:nvPr/>
-        </p:nvSpPr>
-        <p:spPr>
-          <a:xfrm>
-            <a:off x="2249424" y="4700016"/>
-            <a:ext cx="8991295" cy="969264"/>
-          </a:xfrm>
-          <a:prstGeom prst="rect">
-            <a:avLst/>
-          </a:prstGeom>
-          <a:noFill/>
-          <a:ln/>
-        </p:spPr>
-        <p:txBody>
-          <a:bodyPr wrap="square" lIns="0" tIns="0" rIns="0" bIns="0" rtlCol="0" anchor="ctr"/>
-          <a:lstStyle/>
-          <a:p>
+          <p:cNvPr id="48" name="Text 46"/>
+          <p:cNvSpPr txBox="1"/>
+          <p:nvPr/>
+        </p:nvSpPr>
+        <p:spPr>
+          <a:xfrm>
+            <a:off x="2249424" y="4736592"/>
+            <a:ext cx="8991295" cy="914400"/>
+          </a:xfrm>
+          <a:prstGeom prst="rect">
+            <a:avLst/>
+          </a:prstGeom>
+          <a:noFill/>
+          <a:ln/>
+        </p:spPr>
+        <p:txBody>
+          <a:bodyPr wrap="square" lIns="0" tIns="0" rIns="0" bIns="0" rtlCol="0" anchor="ctr"/>
+          <a:lstStyle/>
+          <a:p>
+            <a:pPr indent="0" marL="0">
+              <a:buNone/>
+            </a:pPr>
+            <a:r>
+              <a:rPr lang="en-US" sz="1250" dirty="0">
+                <a:solidFill>
+                  <a:srgbClr val="7E6242"/>
+                </a:solidFill>
+                <a:latin typeface="Calibri" pitchFamily="34" charset="0"/>
+                <a:ea typeface="Calibri" pitchFamily="34" charset="-122"/>
+                <a:cs typeface="Calibri" pitchFamily="34" charset="-120"/>
+              </a:rPr>
+              <a:t>추측하지 않고 </a:t>
+            </a:r>
             <a:pPr indent="0" marL="0">
               <a:buNone/>
             </a:pPr>
@@ -15944,7 +16174,7 @@
                 <a:ea typeface="Calibri" pitchFamily="34" charset="-122"/>
                 <a:cs typeface="Calibri" pitchFamily="34" charset="-120"/>
               </a:rPr>
-              <a:t>Systematic Debugging</a:t>
+              <a:t>재현 → 증거 → 원인</a:t>
             </a:r>
             <a:pPr indent="0" marL="0">
               <a:buNone/>
@@ -15958,7 +16188,7 @@
                 <a:ea typeface="Calibri" pitchFamily="34" charset="-122"/>
                 <a:cs typeface="Calibri" pitchFamily="34" charset="-120"/>
               </a:rPr>
-              <a:t> 으로 재현 → 증거 → 원인을 확인한 뒤, 멈췄던 단계로 돌아갑니다.</a:t>
+              <a:t> 순으로 확인한 뒤, 멈췄던 단계로 돌아갑니다. (Systematic Debugging)</a:t>
             </a:r>
             <a:endParaRPr lang="en-US" sz="1250" dirty="0"/>
           </a:p>
@@ -15966,7 +16196,7 @@
       </p:sp>
       <p:sp>
         <p:nvSpPr>
-          <p:cNvPr id="45" name="Text 43"/>
+          <p:cNvPr id="49" name="Text 47"/>
           <p:cNvSpPr txBox="1"/>
           <p:nvPr/>
         </p:nvSpPr>
@@ -15997,7 +16227,7 @@
                 <a:ea typeface="Calibri" pitchFamily="34" charset="-122"/>
                 <a:cs typeface="Calibri" pitchFamily="34" charset="-120"/>
               </a:rPr>
-              <a:t>Superpowers가 각 단계에 어떤 Skill을 쓰는지는 다음 장부터 살펴봅니다.</a:t>
+              <a:t>TDD = 실패하는 테스트를 먼저 쓰고, 그 테스트를 통과시키는 코드를 쓰는 방식 · 각 단계에 쓰이는 Skill은 다음 장부터 살펴봅니다.</a:t>
             </a:r>
             <a:endParaRPr lang="en-US" sz="950" dirty="0"/>
           </a:p>

</xml_diff>